<commit_message>
WB 2026 deck v3: fix actual-side silhouette + cluster mini-map silhouette (dim fill not hollow)
Co-Authored-By: Claude Sonnet 4.6 <noreply@anthropic.com>
</commit_message>
<xml_diff>
--- a/engineering/wb_2026_postmortem_deck.pptx
+++ b/engineering/wb_2026_postmortem_deck.pptx
@@ -2706,14 +2706,11 @@
             <a:avLst/>
           </a:prstGeom>
           <a:solidFill>
-            <a:srgbClr val="050505"/>
-          </a:solidFill>
-          <a:ln w="6350">
-            <a:solidFill>
-              <a:srgbClr val="3A3A38"/>
-            </a:solidFill>
-            <a:prstDash val="solid"/>
-          </a:ln>
+            <a:srgbClr val="E9E6DF">
+              <a:alpha val="12000"/>
+            </a:srgbClr>
+          </a:solidFill>
+          <a:ln/>
         </p:spPr>
       </p:sp>
       <p:sp>
@@ -2733,12 +2730,7 @@
           <a:solidFill>
             <a:srgbClr val="A8FF3E"/>
           </a:solidFill>
-          <a:ln w="6350">
-            <a:solidFill>
-              <a:srgbClr val="A8FF3E"/>
-            </a:solidFill>
-            <a:prstDash val="solid"/>
-          </a:ln>
+          <a:ln/>
         </p:spPr>
       </p:sp>
       <p:sp>
@@ -2758,12 +2750,7 @@
           <a:solidFill>
             <a:srgbClr val="A8FF3E"/>
           </a:solidFill>
-          <a:ln w="6350">
-            <a:solidFill>
-              <a:srgbClr val="A8FF3E"/>
-            </a:solidFill>
-            <a:prstDash val="solid"/>
-          </a:ln>
+          <a:ln/>
         </p:spPr>
       </p:sp>
       <p:sp>
@@ -2781,14 +2768,11 @@
             <a:avLst/>
           </a:prstGeom>
           <a:solidFill>
-            <a:srgbClr val="050505"/>
-          </a:solidFill>
-          <a:ln w="6350">
-            <a:solidFill>
-              <a:srgbClr val="3A3A38"/>
-            </a:solidFill>
-            <a:prstDash val="solid"/>
-          </a:ln>
+            <a:srgbClr val="E9E6DF">
+              <a:alpha val="12000"/>
+            </a:srgbClr>
+          </a:solidFill>
+          <a:ln/>
         </p:spPr>
       </p:sp>
       <p:sp>
@@ -2806,14 +2790,11 @@
             <a:avLst/>
           </a:prstGeom>
           <a:solidFill>
-            <a:srgbClr val="050505"/>
-          </a:solidFill>
-          <a:ln w="6350">
-            <a:solidFill>
-              <a:srgbClr val="3A3A38"/>
-            </a:solidFill>
-            <a:prstDash val="solid"/>
-          </a:ln>
+            <a:srgbClr val="E9E6DF">
+              <a:alpha val="12000"/>
+            </a:srgbClr>
+          </a:solidFill>
+          <a:ln/>
         </p:spPr>
       </p:sp>
       <p:sp>
@@ -2831,14 +2812,11 @@
             <a:avLst/>
           </a:prstGeom>
           <a:solidFill>
-            <a:srgbClr val="050505"/>
-          </a:solidFill>
-          <a:ln w="6350">
-            <a:solidFill>
-              <a:srgbClr val="3A3A38"/>
-            </a:solidFill>
-            <a:prstDash val="solid"/>
-          </a:ln>
+            <a:srgbClr val="E9E6DF">
+              <a:alpha val="12000"/>
+            </a:srgbClr>
+          </a:solidFill>
+          <a:ln/>
         </p:spPr>
       </p:sp>
       <p:sp>
@@ -2856,14 +2834,11 @@
             <a:avLst/>
           </a:prstGeom>
           <a:solidFill>
-            <a:srgbClr val="050505"/>
-          </a:solidFill>
-          <a:ln w="6350">
-            <a:solidFill>
-              <a:srgbClr val="3A3A38"/>
-            </a:solidFill>
-            <a:prstDash val="solid"/>
-          </a:ln>
+            <a:srgbClr val="E9E6DF">
+              <a:alpha val="12000"/>
+            </a:srgbClr>
+          </a:solidFill>
+          <a:ln/>
         </p:spPr>
       </p:sp>
       <p:sp>
@@ -2881,14 +2856,11 @@
             <a:avLst/>
           </a:prstGeom>
           <a:solidFill>
-            <a:srgbClr val="050505"/>
-          </a:solidFill>
-          <a:ln w="6350">
-            <a:solidFill>
-              <a:srgbClr val="3A3A38"/>
-            </a:solidFill>
-            <a:prstDash val="solid"/>
-          </a:ln>
+            <a:srgbClr val="E9E6DF">
+              <a:alpha val="12000"/>
+            </a:srgbClr>
+          </a:solidFill>
+          <a:ln/>
         </p:spPr>
       </p:sp>
       <p:sp>
@@ -2906,14 +2878,11 @@
             <a:avLst/>
           </a:prstGeom>
           <a:solidFill>
-            <a:srgbClr val="050505"/>
-          </a:solidFill>
-          <a:ln w="6350">
-            <a:solidFill>
-              <a:srgbClr val="3A3A38"/>
-            </a:solidFill>
-            <a:prstDash val="solid"/>
-          </a:ln>
+            <a:srgbClr val="E9E6DF">
+              <a:alpha val="12000"/>
+            </a:srgbClr>
+          </a:solidFill>
+          <a:ln/>
         </p:spPr>
       </p:sp>
       <p:sp>
@@ -2931,14 +2900,11 @@
             <a:avLst/>
           </a:prstGeom>
           <a:solidFill>
-            <a:srgbClr val="050505"/>
-          </a:solidFill>
-          <a:ln w="6350">
-            <a:solidFill>
-              <a:srgbClr val="3A3A38"/>
-            </a:solidFill>
-            <a:prstDash val="solid"/>
-          </a:ln>
+            <a:srgbClr val="E9E6DF">
+              <a:alpha val="12000"/>
+            </a:srgbClr>
+          </a:solidFill>
+          <a:ln/>
         </p:spPr>
       </p:sp>
       <p:sp>
@@ -2956,14 +2922,11 @@
             <a:avLst/>
           </a:prstGeom>
           <a:solidFill>
-            <a:srgbClr val="050505"/>
-          </a:solidFill>
-          <a:ln w="6350">
-            <a:solidFill>
-              <a:srgbClr val="3A3A38"/>
-            </a:solidFill>
-            <a:prstDash val="solid"/>
-          </a:ln>
+            <a:srgbClr val="E9E6DF">
+              <a:alpha val="12000"/>
+            </a:srgbClr>
+          </a:solidFill>
+          <a:ln/>
         </p:spPr>
       </p:sp>
       <p:sp>
@@ -2981,14 +2944,11 @@
             <a:avLst/>
           </a:prstGeom>
           <a:solidFill>
-            <a:srgbClr val="050505"/>
-          </a:solidFill>
-          <a:ln w="6350">
-            <a:solidFill>
-              <a:srgbClr val="3A3A38"/>
-            </a:solidFill>
-            <a:prstDash val="solid"/>
-          </a:ln>
+            <a:srgbClr val="E9E6DF">
+              <a:alpha val="12000"/>
+            </a:srgbClr>
+          </a:solidFill>
+          <a:ln/>
         </p:spPr>
       </p:sp>
       <p:sp>
@@ -3006,14 +2966,11 @@
             <a:avLst/>
           </a:prstGeom>
           <a:solidFill>
-            <a:srgbClr val="050505"/>
-          </a:solidFill>
-          <a:ln w="6350">
-            <a:solidFill>
-              <a:srgbClr val="3A3A38"/>
-            </a:solidFill>
-            <a:prstDash val="solid"/>
-          </a:ln>
+            <a:srgbClr val="E9E6DF">
+              <a:alpha val="12000"/>
+            </a:srgbClr>
+          </a:solidFill>
+          <a:ln/>
         </p:spPr>
       </p:sp>
       <p:sp>
@@ -3031,14 +2988,11 @@
             <a:avLst/>
           </a:prstGeom>
           <a:solidFill>
-            <a:srgbClr val="050505"/>
-          </a:solidFill>
-          <a:ln w="6350">
-            <a:solidFill>
-              <a:srgbClr val="3A3A38"/>
-            </a:solidFill>
-            <a:prstDash val="solid"/>
-          </a:ln>
+            <a:srgbClr val="E9E6DF">
+              <a:alpha val="12000"/>
+            </a:srgbClr>
+          </a:solidFill>
+          <a:ln/>
         </p:spPr>
       </p:sp>
       <p:sp>
@@ -3269,7 +3223,7 @@
                 <a:ea typeface="Courier New" pitchFamily="34" charset="-122"/>
                 <a:cs typeface="Courier New" pitchFamily="34" charset="-120"/>
               </a:rPr>
-              <a:t>MATUA</a:t>
+              <a:t>MATUA / N24</a:t>
             </a:r>
             <a:endParaRPr lang="en-US" sz="600" dirty="0"/>
           </a:p>
@@ -4239,14 +4193,11 @@
             <a:avLst/>
           </a:prstGeom>
           <a:solidFill>
-            <a:srgbClr val="050505"/>
-          </a:solidFill>
-          <a:ln w="6350">
-            <a:solidFill>
-              <a:srgbClr val="3A3A38"/>
-            </a:solidFill>
-            <a:prstDash val="solid"/>
-          </a:ln>
+            <a:srgbClr val="E9E6DF">
+              <a:alpha val="12000"/>
+            </a:srgbClr>
+          </a:solidFill>
+          <a:ln/>
         </p:spPr>
       </p:sp>
       <p:sp>
@@ -4264,14 +4215,11 @@
             <a:avLst/>
           </a:prstGeom>
           <a:solidFill>
-            <a:srgbClr val="050505"/>
-          </a:solidFill>
-          <a:ln w="6350">
-            <a:solidFill>
-              <a:srgbClr val="3A3A38"/>
-            </a:solidFill>
-            <a:prstDash val="solid"/>
-          </a:ln>
+            <a:srgbClr val="E9E6DF">
+              <a:alpha val="12000"/>
+            </a:srgbClr>
+          </a:solidFill>
+          <a:ln/>
         </p:spPr>
       </p:sp>
       <p:sp>
@@ -4289,14 +4237,11 @@
             <a:avLst/>
           </a:prstGeom>
           <a:solidFill>
-            <a:srgbClr val="050505"/>
-          </a:solidFill>
-          <a:ln w="6350">
-            <a:solidFill>
-              <a:srgbClr val="3A3A38"/>
-            </a:solidFill>
-            <a:prstDash val="solid"/>
-          </a:ln>
+            <a:srgbClr val="E9E6DF">
+              <a:alpha val="12000"/>
+            </a:srgbClr>
+          </a:solidFill>
+          <a:ln/>
         </p:spPr>
       </p:sp>
       <p:sp>
@@ -4314,14 +4259,11 @@
             <a:avLst/>
           </a:prstGeom>
           <a:solidFill>
-            <a:srgbClr val="050505"/>
-          </a:solidFill>
-          <a:ln w="6350">
-            <a:solidFill>
-              <a:srgbClr val="3A3A38"/>
-            </a:solidFill>
-            <a:prstDash val="solid"/>
-          </a:ln>
+            <a:srgbClr val="E9E6DF">
+              <a:alpha val="12000"/>
+            </a:srgbClr>
+          </a:solidFill>
+          <a:ln/>
         </p:spPr>
       </p:sp>
       <p:sp>
@@ -4341,12 +4283,7 @@
           <a:solidFill>
             <a:srgbClr val="A8FF3E"/>
           </a:solidFill>
-          <a:ln w="6350">
-            <a:solidFill>
-              <a:srgbClr val="A8FF3E"/>
-            </a:solidFill>
-            <a:prstDash val="solid"/>
-          </a:ln>
+          <a:ln/>
         </p:spPr>
       </p:sp>
       <p:sp>
@@ -4364,14 +4301,11 @@
             <a:avLst/>
           </a:prstGeom>
           <a:solidFill>
-            <a:srgbClr val="050505"/>
-          </a:solidFill>
-          <a:ln w="6350">
-            <a:solidFill>
-              <a:srgbClr val="3A3A38"/>
-            </a:solidFill>
-            <a:prstDash val="solid"/>
-          </a:ln>
+            <a:srgbClr val="E9E6DF">
+              <a:alpha val="12000"/>
+            </a:srgbClr>
+          </a:solidFill>
+          <a:ln/>
         </p:spPr>
       </p:sp>
       <p:sp>
@@ -4389,14 +4323,11 @@
             <a:avLst/>
           </a:prstGeom>
           <a:solidFill>
-            <a:srgbClr val="050505"/>
-          </a:solidFill>
-          <a:ln w="6350">
-            <a:solidFill>
-              <a:srgbClr val="3A3A38"/>
-            </a:solidFill>
-            <a:prstDash val="solid"/>
-          </a:ln>
+            <a:srgbClr val="E9E6DF">
+              <a:alpha val="12000"/>
+            </a:srgbClr>
+          </a:solidFill>
+          <a:ln/>
         </p:spPr>
       </p:sp>
       <p:sp>
@@ -4414,14 +4345,11 @@
             <a:avLst/>
           </a:prstGeom>
           <a:solidFill>
-            <a:srgbClr val="050505"/>
-          </a:solidFill>
-          <a:ln w="6350">
-            <a:solidFill>
-              <a:srgbClr val="3A3A38"/>
-            </a:solidFill>
-            <a:prstDash val="solid"/>
-          </a:ln>
+            <a:srgbClr val="E9E6DF">
+              <a:alpha val="12000"/>
+            </a:srgbClr>
+          </a:solidFill>
+          <a:ln/>
         </p:spPr>
       </p:sp>
       <p:sp>
@@ -4439,14 +4367,11 @@
             <a:avLst/>
           </a:prstGeom>
           <a:solidFill>
-            <a:srgbClr val="050505"/>
-          </a:solidFill>
-          <a:ln w="6350">
-            <a:solidFill>
-              <a:srgbClr val="3A3A38"/>
-            </a:solidFill>
-            <a:prstDash val="solid"/>
-          </a:ln>
+            <a:srgbClr val="E9E6DF">
+              <a:alpha val="12000"/>
+            </a:srgbClr>
+          </a:solidFill>
+          <a:ln/>
         </p:spPr>
       </p:sp>
       <p:sp>
@@ -4464,14 +4389,11 @@
             <a:avLst/>
           </a:prstGeom>
           <a:solidFill>
-            <a:srgbClr val="050505"/>
-          </a:solidFill>
-          <a:ln w="6350">
-            <a:solidFill>
-              <a:srgbClr val="3A3A38"/>
-            </a:solidFill>
-            <a:prstDash val="solid"/>
-          </a:ln>
+            <a:srgbClr val="E9E6DF">
+              <a:alpha val="12000"/>
+            </a:srgbClr>
+          </a:solidFill>
+          <a:ln/>
         </p:spPr>
       </p:sp>
       <p:sp>
@@ -4489,14 +4411,11 @@
             <a:avLst/>
           </a:prstGeom>
           <a:solidFill>
-            <a:srgbClr val="050505"/>
-          </a:solidFill>
-          <a:ln w="6350">
-            <a:solidFill>
-              <a:srgbClr val="3A3A38"/>
-            </a:solidFill>
-            <a:prstDash val="solid"/>
-          </a:ln>
+            <a:srgbClr val="E9E6DF">
+              <a:alpha val="12000"/>
+            </a:srgbClr>
+          </a:solidFill>
+          <a:ln/>
         </p:spPr>
       </p:sp>
       <p:sp>
@@ -4514,14 +4433,11 @@
             <a:avLst/>
           </a:prstGeom>
           <a:solidFill>
-            <a:srgbClr val="050505"/>
-          </a:solidFill>
-          <a:ln w="6350">
-            <a:solidFill>
-              <a:srgbClr val="3A3A38"/>
-            </a:solidFill>
-            <a:prstDash val="solid"/>
-          </a:ln>
+            <a:srgbClr val="E9E6DF">
+              <a:alpha val="12000"/>
+            </a:srgbClr>
+          </a:solidFill>
+          <a:ln/>
         </p:spPr>
       </p:sp>
       <p:sp>
@@ -4539,14 +4455,11 @@
             <a:avLst/>
           </a:prstGeom>
           <a:solidFill>
-            <a:srgbClr val="050505"/>
-          </a:solidFill>
-          <a:ln w="6350">
-            <a:solidFill>
-              <a:srgbClr val="3A3A38"/>
-            </a:solidFill>
-            <a:prstDash val="solid"/>
-          </a:ln>
+            <a:srgbClr val="E9E6DF">
+              <a:alpha val="12000"/>
+            </a:srgbClr>
+          </a:solidFill>
+          <a:ln/>
         </p:spPr>
       </p:sp>
       <p:sp>
@@ -4564,14 +4477,11 @@
             <a:avLst/>
           </a:prstGeom>
           <a:solidFill>
-            <a:srgbClr val="050505"/>
-          </a:solidFill>
-          <a:ln w="6350">
-            <a:solidFill>
-              <a:srgbClr val="3A3A38"/>
-            </a:solidFill>
-            <a:prstDash val="solid"/>
-          </a:ln>
+            <a:srgbClr val="E9E6DF">
+              <a:alpha val="12000"/>
+            </a:srgbClr>
+          </a:solidFill>
+          <a:ln/>
         </p:spPr>
       </p:sp>
       <p:sp>
@@ -4802,7 +4712,7 @@
                 <a:ea typeface="Courier New" pitchFamily="34" charset="-122"/>
                 <a:cs typeface="Courier New" pitchFamily="34" charset="-120"/>
               </a:rPr>
-              <a:t>MATUA</a:t>
+              <a:t>MATUA / N24</a:t>
             </a:r>
             <a:endParaRPr lang="en-US" sz="600" dirty="0"/>
           </a:p>
@@ -5772,14 +5682,11 @@
             <a:avLst/>
           </a:prstGeom>
           <a:solidFill>
-            <a:srgbClr val="050505"/>
-          </a:solidFill>
-          <a:ln w="6350">
-            <a:solidFill>
-              <a:srgbClr val="3A3A38"/>
-            </a:solidFill>
-            <a:prstDash val="solid"/>
-          </a:ln>
+            <a:srgbClr val="E9E6DF">
+              <a:alpha val="12000"/>
+            </a:srgbClr>
+          </a:solidFill>
+          <a:ln/>
         </p:spPr>
       </p:sp>
       <p:sp>
@@ -5797,14 +5704,11 @@
             <a:avLst/>
           </a:prstGeom>
           <a:solidFill>
-            <a:srgbClr val="050505"/>
-          </a:solidFill>
-          <a:ln w="6350">
-            <a:solidFill>
-              <a:srgbClr val="3A3A38"/>
-            </a:solidFill>
-            <a:prstDash val="solid"/>
-          </a:ln>
+            <a:srgbClr val="E9E6DF">
+              <a:alpha val="12000"/>
+            </a:srgbClr>
+          </a:solidFill>
+          <a:ln/>
         </p:spPr>
       </p:sp>
       <p:sp>
@@ -5822,14 +5726,11 @@
             <a:avLst/>
           </a:prstGeom>
           <a:solidFill>
-            <a:srgbClr val="050505"/>
-          </a:solidFill>
-          <a:ln w="6350">
-            <a:solidFill>
-              <a:srgbClr val="3A3A38"/>
-            </a:solidFill>
-            <a:prstDash val="solid"/>
-          </a:ln>
+            <a:srgbClr val="E9E6DF">
+              <a:alpha val="12000"/>
+            </a:srgbClr>
+          </a:solidFill>
+          <a:ln/>
         </p:spPr>
       </p:sp>
       <p:sp>
@@ -5849,12 +5750,7 @@
           <a:solidFill>
             <a:srgbClr val="A8FF3E"/>
           </a:solidFill>
-          <a:ln w="6350">
-            <a:solidFill>
-              <a:srgbClr val="A8FF3E"/>
-            </a:solidFill>
-            <a:prstDash val="solid"/>
-          </a:ln>
+          <a:ln/>
         </p:spPr>
       </p:sp>
       <p:sp>
@@ -5872,14 +5768,11 @@
             <a:avLst/>
           </a:prstGeom>
           <a:solidFill>
-            <a:srgbClr val="050505"/>
-          </a:solidFill>
-          <a:ln w="6350">
-            <a:solidFill>
-              <a:srgbClr val="3A3A38"/>
-            </a:solidFill>
-            <a:prstDash val="solid"/>
-          </a:ln>
+            <a:srgbClr val="E9E6DF">
+              <a:alpha val="12000"/>
+            </a:srgbClr>
+          </a:solidFill>
+          <a:ln/>
         </p:spPr>
       </p:sp>
       <p:sp>
@@ -5897,14 +5790,11 @@
             <a:avLst/>
           </a:prstGeom>
           <a:solidFill>
-            <a:srgbClr val="050505"/>
-          </a:solidFill>
-          <a:ln w="6350">
-            <a:solidFill>
-              <a:srgbClr val="3A3A38"/>
-            </a:solidFill>
-            <a:prstDash val="solid"/>
-          </a:ln>
+            <a:srgbClr val="E9E6DF">
+              <a:alpha val="12000"/>
+            </a:srgbClr>
+          </a:solidFill>
+          <a:ln/>
         </p:spPr>
       </p:sp>
       <p:sp>
@@ -5922,14 +5812,11 @@
             <a:avLst/>
           </a:prstGeom>
           <a:solidFill>
-            <a:srgbClr val="050505"/>
-          </a:solidFill>
-          <a:ln w="6350">
-            <a:solidFill>
-              <a:srgbClr val="3A3A38"/>
-            </a:solidFill>
-            <a:prstDash val="solid"/>
-          </a:ln>
+            <a:srgbClr val="E9E6DF">
+              <a:alpha val="12000"/>
+            </a:srgbClr>
+          </a:solidFill>
+          <a:ln/>
         </p:spPr>
       </p:sp>
       <p:sp>
@@ -5947,14 +5834,11 @@
             <a:avLst/>
           </a:prstGeom>
           <a:solidFill>
-            <a:srgbClr val="050505"/>
-          </a:solidFill>
-          <a:ln w="6350">
-            <a:solidFill>
-              <a:srgbClr val="3A3A38"/>
-            </a:solidFill>
-            <a:prstDash val="solid"/>
-          </a:ln>
+            <a:srgbClr val="E9E6DF">
+              <a:alpha val="12000"/>
+            </a:srgbClr>
+          </a:solidFill>
+          <a:ln/>
         </p:spPr>
       </p:sp>
       <p:sp>
@@ -5972,14 +5856,11 @@
             <a:avLst/>
           </a:prstGeom>
           <a:solidFill>
-            <a:srgbClr val="050505"/>
-          </a:solidFill>
-          <a:ln w="6350">
-            <a:solidFill>
-              <a:srgbClr val="3A3A38"/>
-            </a:solidFill>
-            <a:prstDash val="solid"/>
-          </a:ln>
+            <a:srgbClr val="E9E6DF">
+              <a:alpha val="12000"/>
+            </a:srgbClr>
+          </a:solidFill>
+          <a:ln/>
         </p:spPr>
       </p:sp>
       <p:sp>
@@ -5997,14 +5878,11 @@
             <a:avLst/>
           </a:prstGeom>
           <a:solidFill>
-            <a:srgbClr val="050505"/>
-          </a:solidFill>
-          <a:ln w="6350">
-            <a:solidFill>
-              <a:srgbClr val="3A3A38"/>
-            </a:solidFill>
-            <a:prstDash val="solid"/>
-          </a:ln>
+            <a:srgbClr val="E9E6DF">
+              <a:alpha val="12000"/>
+            </a:srgbClr>
+          </a:solidFill>
+          <a:ln/>
         </p:spPr>
       </p:sp>
       <p:sp>
@@ -6022,14 +5900,11 @@
             <a:avLst/>
           </a:prstGeom>
           <a:solidFill>
-            <a:srgbClr val="050505"/>
-          </a:solidFill>
-          <a:ln w="6350">
-            <a:solidFill>
-              <a:srgbClr val="3A3A38"/>
-            </a:solidFill>
-            <a:prstDash val="solid"/>
-          </a:ln>
+            <a:srgbClr val="E9E6DF">
+              <a:alpha val="12000"/>
+            </a:srgbClr>
+          </a:solidFill>
+          <a:ln/>
         </p:spPr>
       </p:sp>
       <p:sp>
@@ -6047,14 +5922,11 @@
             <a:avLst/>
           </a:prstGeom>
           <a:solidFill>
-            <a:srgbClr val="050505"/>
-          </a:solidFill>
-          <a:ln w="6350">
-            <a:solidFill>
-              <a:srgbClr val="3A3A38"/>
-            </a:solidFill>
-            <a:prstDash val="solid"/>
-          </a:ln>
+            <a:srgbClr val="E9E6DF">
+              <a:alpha val="12000"/>
+            </a:srgbClr>
+          </a:solidFill>
+          <a:ln/>
         </p:spPr>
       </p:sp>
       <p:sp>
@@ -6072,14 +5944,11 @@
             <a:avLst/>
           </a:prstGeom>
           <a:solidFill>
-            <a:srgbClr val="050505"/>
-          </a:solidFill>
-          <a:ln w="6350">
-            <a:solidFill>
-              <a:srgbClr val="3A3A38"/>
-            </a:solidFill>
-            <a:prstDash val="solid"/>
-          </a:ln>
+            <a:srgbClr val="E9E6DF">
+              <a:alpha val="12000"/>
+            </a:srgbClr>
+          </a:solidFill>
+          <a:ln/>
         </p:spPr>
       </p:sp>
       <p:sp>
@@ -6097,14 +5966,11 @@
             <a:avLst/>
           </a:prstGeom>
           <a:solidFill>
-            <a:srgbClr val="050505"/>
-          </a:solidFill>
-          <a:ln w="6350">
-            <a:solidFill>
-              <a:srgbClr val="3A3A38"/>
-            </a:solidFill>
-            <a:prstDash val="solid"/>
-          </a:ln>
+            <a:srgbClr val="E9E6DF">
+              <a:alpha val="12000"/>
+            </a:srgbClr>
+          </a:solidFill>
+          <a:ln/>
         </p:spPr>
       </p:sp>
       <p:sp>
@@ -6335,7 +6201,7 @@
                 <a:ea typeface="Courier New" pitchFamily="34" charset="-122"/>
                 <a:cs typeface="Courier New" pitchFamily="34" charset="-120"/>
               </a:rPr>
-              <a:t>MATUA</a:t>
+              <a:t>MATUA / N24</a:t>
             </a:r>
             <a:endParaRPr lang="en-US" sz="600" dirty="0"/>
           </a:p>
@@ -7307,12 +7173,7 @@
           <a:solidFill>
             <a:srgbClr val="A8FF3E"/>
           </a:solidFill>
-          <a:ln w="6350">
-            <a:solidFill>
-              <a:srgbClr val="A8FF3E"/>
-            </a:solidFill>
-            <a:prstDash val="solid"/>
-          </a:ln>
+          <a:ln/>
         </p:spPr>
       </p:sp>
       <p:sp>
@@ -7330,14 +7191,11 @@
             <a:avLst/>
           </a:prstGeom>
           <a:solidFill>
-            <a:srgbClr val="050505"/>
-          </a:solidFill>
-          <a:ln w="6350">
-            <a:solidFill>
-              <a:srgbClr val="3A3A38"/>
-            </a:solidFill>
-            <a:prstDash val="solid"/>
-          </a:ln>
+            <a:srgbClr val="E9E6DF">
+              <a:alpha val="12000"/>
+            </a:srgbClr>
+          </a:solidFill>
+          <a:ln/>
         </p:spPr>
       </p:sp>
       <p:sp>
@@ -7355,14 +7213,11 @@
             <a:avLst/>
           </a:prstGeom>
           <a:solidFill>
-            <a:srgbClr val="050505"/>
-          </a:solidFill>
-          <a:ln w="6350">
-            <a:solidFill>
-              <a:srgbClr val="3A3A38"/>
-            </a:solidFill>
-            <a:prstDash val="solid"/>
-          </a:ln>
+            <a:srgbClr val="E9E6DF">
+              <a:alpha val="12000"/>
+            </a:srgbClr>
+          </a:solidFill>
+          <a:ln/>
         </p:spPr>
       </p:sp>
       <p:sp>
@@ -7380,14 +7235,11 @@
             <a:avLst/>
           </a:prstGeom>
           <a:solidFill>
-            <a:srgbClr val="050505"/>
-          </a:solidFill>
-          <a:ln w="6350">
-            <a:solidFill>
-              <a:srgbClr val="3A3A38"/>
-            </a:solidFill>
-            <a:prstDash val="solid"/>
-          </a:ln>
+            <a:srgbClr val="E9E6DF">
+              <a:alpha val="12000"/>
+            </a:srgbClr>
+          </a:solidFill>
+          <a:ln/>
         </p:spPr>
       </p:sp>
       <p:sp>
@@ -7405,14 +7257,11 @@
             <a:avLst/>
           </a:prstGeom>
           <a:solidFill>
-            <a:srgbClr val="050505"/>
-          </a:solidFill>
-          <a:ln w="6350">
-            <a:solidFill>
-              <a:srgbClr val="3A3A38"/>
-            </a:solidFill>
-            <a:prstDash val="solid"/>
-          </a:ln>
+            <a:srgbClr val="E9E6DF">
+              <a:alpha val="12000"/>
+            </a:srgbClr>
+          </a:solidFill>
+          <a:ln/>
         </p:spPr>
       </p:sp>
       <p:sp>
@@ -7430,14 +7279,11 @@
             <a:avLst/>
           </a:prstGeom>
           <a:solidFill>
-            <a:srgbClr val="050505"/>
-          </a:solidFill>
-          <a:ln w="6350">
-            <a:solidFill>
-              <a:srgbClr val="3A3A38"/>
-            </a:solidFill>
-            <a:prstDash val="solid"/>
-          </a:ln>
+            <a:srgbClr val="E9E6DF">
+              <a:alpha val="12000"/>
+            </a:srgbClr>
+          </a:solidFill>
+          <a:ln/>
         </p:spPr>
       </p:sp>
       <p:sp>
@@ -7455,14 +7301,11 @@
             <a:avLst/>
           </a:prstGeom>
           <a:solidFill>
-            <a:srgbClr val="050505"/>
-          </a:solidFill>
-          <a:ln w="6350">
-            <a:solidFill>
-              <a:srgbClr val="3A3A38"/>
-            </a:solidFill>
-            <a:prstDash val="solid"/>
-          </a:ln>
+            <a:srgbClr val="E9E6DF">
+              <a:alpha val="12000"/>
+            </a:srgbClr>
+          </a:solidFill>
+          <a:ln/>
         </p:spPr>
       </p:sp>
       <p:sp>
@@ -7480,14 +7323,11 @@
             <a:avLst/>
           </a:prstGeom>
           <a:solidFill>
-            <a:srgbClr val="050505"/>
-          </a:solidFill>
-          <a:ln w="6350">
-            <a:solidFill>
-              <a:srgbClr val="3A3A38"/>
-            </a:solidFill>
-            <a:prstDash val="solid"/>
-          </a:ln>
+            <a:srgbClr val="E9E6DF">
+              <a:alpha val="12000"/>
+            </a:srgbClr>
+          </a:solidFill>
+          <a:ln/>
         </p:spPr>
       </p:sp>
       <p:sp>
@@ -7505,14 +7345,11 @@
             <a:avLst/>
           </a:prstGeom>
           <a:solidFill>
-            <a:srgbClr val="050505"/>
-          </a:solidFill>
-          <a:ln w="6350">
-            <a:solidFill>
-              <a:srgbClr val="3A3A38"/>
-            </a:solidFill>
-            <a:prstDash val="solid"/>
-          </a:ln>
+            <a:srgbClr val="E9E6DF">
+              <a:alpha val="12000"/>
+            </a:srgbClr>
+          </a:solidFill>
+          <a:ln/>
         </p:spPr>
       </p:sp>
       <p:sp>
@@ -7530,14 +7367,11 @@
             <a:avLst/>
           </a:prstGeom>
           <a:solidFill>
-            <a:srgbClr val="050505"/>
-          </a:solidFill>
-          <a:ln w="6350">
-            <a:solidFill>
-              <a:srgbClr val="3A3A38"/>
-            </a:solidFill>
-            <a:prstDash val="solid"/>
-          </a:ln>
+            <a:srgbClr val="E9E6DF">
+              <a:alpha val="12000"/>
+            </a:srgbClr>
+          </a:solidFill>
+          <a:ln/>
         </p:spPr>
       </p:sp>
       <p:sp>
@@ -7555,14 +7389,11 @@
             <a:avLst/>
           </a:prstGeom>
           <a:solidFill>
-            <a:srgbClr val="050505"/>
-          </a:solidFill>
-          <a:ln w="6350">
-            <a:solidFill>
-              <a:srgbClr val="3A3A38"/>
-            </a:solidFill>
-            <a:prstDash val="solid"/>
-          </a:ln>
+            <a:srgbClr val="E9E6DF">
+              <a:alpha val="12000"/>
+            </a:srgbClr>
+          </a:solidFill>
+          <a:ln/>
         </p:spPr>
       </p:sp>
       <p:sp>
@@ -7580,14 +7411,11 @@
             <a:avLst/>
           </a:prstGeom>
           <a:solidFill>
-            <a:srgbClr val="050505"/>
-          </a:solidFill>
-          <a:ln w="6350">
-            <a:solidFill>
-              <a:srgbClr val="3A3A38"/>
-            </a:solidFill>
-            <a:prstDash val="solid"/>
-          </a:ln>
+            <a:srgbClr val="E9E6DF">
+              <a:alpha val="12000"/>
+            </a:srgbClr>
+          </a:solidFill>
+          <a:ln/>
         </p:spPr>
       </p:sp>
       <p:sp>
@@ -7605,14 +7433,11 @@
             <a:avLst/>
           </a:prstGeom>
           <a:solidFill>
-            <a:srgbClr val="050505"/>
-          </a:solidFill>
-          <a:ln w="6350">
-            <a:solidFill>
-              <a:srgbClr val="3A3A38"/>
-            </a:solidFill>
-            <a:prstDash val="solid"/>
-          </a:ln>
+            <a:srgbClr val="E9E6DF">
+              <a:alpha val="12000"/>
+            </a:srgbClr>
+          </a:solidFill>
+          <a:ln/>
         </p:spPr>
       </p:sp>
       <p:sp>
@@ -7630,14 +7455,11 @@
             <a:avLst/>
           </a:prstGeom>
           <a:solidFill>
-            <a:srgbClr val="050505"/>
-          </a:solidFill>
-          <a:ln w="6350">
-            <a:solidFill>
-              <a:srgbClr val="3A3A38"/>
-            </a:solidFill>
-            <a:prstDash val="solid"/>
-          </a:ln>
+            <a:srgbClr val="E9E6DF">
+              <a:alpha val="12000"/>
+            </a:srgbClr>
+          </a:solidFill>
+          <a:ln/>
         </p:spPr>
       </p:sp>
       <p:sp>
@@ -7868,7 +7690,7 @@
                 <a:ea typeface="Courier New" pitchFamily="34" charset="-122"/>
                 <a:cs typeface="Courier New" pitchFamily="34" charset="-120"/>
               </a:rPr>
-              <a:t>MATUA</a:t>
+              <a:t>MATUA / N24</a:t>
             </a:r>
             <a:endParaRPr lang="en-US" sz="600" dirty="0"/>
           </a:p>
@@ -11137,14 +10959,11 @@
             <a:avLst/>
           </a:prstGeom>
           <a:solidFill>
-            <a:srgbClr val="050505"/>
-          </a:solidFill>
-          <a:ln w="6350">
-            <a:solidFill>
-              <a:srgbClr val="E9E6DF"/>
-            </a:solidFill>
-            <a:prstDash val="solid"/>
-          </a:ln>
+            <a:srgbClr val="E9E6DF">
+              <a:alpha val="12000"/>
+            </a:srgbClr>
+          </a:solidFill>
+          <a:ln/>
         </p:spPr>
       </p:sp>
       <p:sp>
@@ -11164,12 +10983,7 @@
           <a:solidFill>
             <a:srgbClr val="E9E6DF"/>
           </a:solidFill>
-          <a:ln w="6350">
-            <a:solidFill>
-              <a:srgbClr val="E9E6DF"/>
-            </a:solidFill>
-            <a:prstDash val="solid"/>
-          </a:ln>
+          <a:ln/>
         </p:spPr>
       </p:sp>
       <p:sp>
@@ -11189,12 +11003,7 @@
           <a:solidFill>
             <a:srgbClr val="E9E6DF"/>
           </a:solidFill>
-          <a:ln w="6350">
-            <a:solidFill>
-              <a:srgbClr val="E9E6DF"/>
-            </a:solidFill>
-            <a:prstDash val="solid"/>
-          </a:ln>
+          <a:ln/>
         </p:spPr>
       </p:sp>
       <p:sp>
@@ -11214,12 +11023,7 @@
           <a:solidFill>
             <a:srgbClr val="E9E6DF"/>
           </a:solidFill>
-          <a:ln w="6350">
-            <a:solidFill>
-              <a:srgbClr val="E9E6DF"/>
-            </a:solidFill>
-            <a:prstDash val="solid"/>
-          </a:ln>
+          <a:ln/>
         </p:spPr>
       </p:sp>
       <p:sp>
@@ -11239,12 +11043,7 @@
           <a:solidFill>
             <a:srgbClr val="E9E6DF"/>
           </a:solidFill>
-          <a:ln w="6350">
-            <a:solidFill>
-              <a:srgbClr val="E9E6DF"/>
-            </a:solidFill>
-            <a:prstDash val="solid"/>
-          </a:ln>
+          <a:ln/>
         </p:spPr>
       </p:sp>
       <p:sp>
@@ -11264,12 +11063,7 @@
           <a:solidFill>
             <a:srgbClr val="E9E6DF"/>
           </a:solidFill>
-          <a:ln w="6350">
-            <a:solidFill>
-              <a:srgbClr val="E9E6DF"/>
-            </a:solidFill>
-            <a:prstDash val="solid"/>
-          </a:ln>
+          <a:ln/>
         </p:spPr>
       </p:sp>
       <p:sp>
@@ -11289,12 +11083,7 @@
           <a:solidFill>
             <a:srgbClr val="E9E6DF"/>
           </a:solidFill>
-          <a:ln w="6350">
-            <a:solidFill>
-              <a:srgbClr val="E9E6DF"/>
-            </a:solidFill>
-            <a:prstDash val="solid"/>
-          </a:ln>
+          <a:ln/>
         </p:spPr>
       </p:sp>
       <p:sp>
@@ -11314,12 +11103,7 @@
           <a:solidFill>
             <a:srgbClr val="E9E6DF"/>
           </a:solidFill>
-          <a:ln w="6350">
-            <a:solidFill>
-              <a:srgbClr val="E9E6DF"/>
-            </a:solidFill>
-            <a:prstDash val="solid"/>
-          </a:ln>
+          <a:ln/>
         </p:spPr>
       </p:sp>
       <p:sp>
@@ -11339,12 +11123,7 @@
           <a:solidFill>
             <a:srgbClr val="E9E6DF"/>
           </a:solidFill>
-          <a:ln w="6350">
-            <a:solidFill>
-              <a:srgbClr val="E9E6DF"/>
-            </a:solidFill>
-            <a:prstDash val="solid"/>
-          </a:ln>
+          <a:ln/>
         </p:spPr>
       </p:sp>
       <p:sp>
@@ -11364,12 +11143,7 @@
           <a:solidFill>
             <a:srgbClr val="E9E6DF"/>
           </a:solidFill>
-          <a:ln w="6350">
-            <a:solidFill>
-              <a:srgbClr val="E9E6DF"/>
-            </a:solidFill>
-            <a:prstDash val="solid"/>
-          </a:ln>
+          <a:ln/>
         </p:spPr>
       </p:sp>
       <p:sp>
@@ -11389,12 +11163,7 @@
           <a:solidFill>
             <a:srgbClr val="E9E6DF"/>
           </a:solidFill>
-          <a:ln w="6350">
-            <a:solidFill>
-              <a:srgbClr val="E9E6DF"/>
-            </a:solidFill>
-            <a:prstDash val="solid"/>
-          </a:ln>
+          <a:ln/>
         </p:spPr>
       </p:sp>
       <p:sp>
@@ -11414,12 +11183,7 @@
           <a:solidFill>
             <a:srgbClr val="E9E6DF"/>
           </a:solidFill>
-          <a:ln w="6350">
-            <a:solidFill>
-              <a:srgbClr val="E9E6DF"/>
-            </a:solidFill>
-            <a:prstDash val="solid"/>
-          </a:ln>
+          <a:ln/>
         </p:spPr>
       </p:sp>
       <p:sp>
@@ -11439,12 +11203,7 @@
           <a:solidFill>
             <a:srgbClr val="E9E6DF"/>
           </a:solidFill>
-          <a:ln w="6350">
-            <a:solidFill>
-              <a:srgbClr val="E9E6DF"/>
-            </a:solidFill>
-            <a:prstDash val="solid"/>
-          </a:ln>
+          <a:ln/>
         </p:spPr>
       </p:sp>
       <p:sp>
@@ -11464,12 +11223,7 @@
           <a:solidFill>
             <a:srgbClr val="E9E6DF"/>
           </a:solidFill>
-          <a:ln w="6350">
-            <a:solidFill>
-              <a:srgbClr val="E9E6DF"/>
-            </a:solidFill>
-            <a:prstDash val="solid"/>
-          </a:ln>
+          <a:ln/>
         </p:spPr>
       </p:sp>
       <p:sp>
@@ -11700,7 +11454,7 @@
                 <a:ea typeface="Courier New" pitchFamily="34" charset="-122"/>
                 <a:cs typeface="Courier New" pitchFamily="34" charset="-120"/>
               </a:rPr>
-              <a:t>MATUA</a:t>
+              <a:t>MATUA / N24</a:t>
             </a:r>
             <a:endParaRPr lang="en-US" sz="700" dirty="0"/>
           </a:p>
@@ -11955,14 +11709,11 @@
             <a:avLst/>
           </a:prstGeom>
           <a:solidFill>
-            <a:srgbClr val="050505"/>
-          </a:solidFill>
-          <a:ln w="6350">
-            <a:solidFill>
-              <a:srgbClr val="E9E6DF"/>
-            </a:solidFill>
-            <a:prstDash val="solid"/>
-          </a:ln>
+            <a:srgbClr val="E9E6DF">
+              <a:alpha val="12000"/>
+            </a:srgbClr>
+          </a:solidFill>
+          <a:ln/>
         </p:spPr>
       </p:sp>
       <p:sp>
@@ -11980,14 +11731,11 @@
             <a:avLst/>
           </a:prstGeom>
           <a:solidFill>
-            <a:srgbClr val="050505"/>
-          </a:solidFill>
-          <a:ln w="6350">
-            <a:solidFill>
-              <a:srgbClr val="E9E6DF"/>
-            </a:solidFill>
-            <a:prstDash val="solid"/>
-          </a:ln>
+            <a:srgbClr val="E9E6DF">
+              <a:alpha val="12000"/>
+            </a:srgbClr>
+          </a:solidFill>
+          <a:ln/>
         </p:spPr>
       </p:sp>
       <p:sp>
@@ -12005,14 +11753,11 @@
             <a:avLst/>
           </a:prstGeom>
           <a:solidFill>
-            <a:srgbClr val="050505"/>
-          </a:solidFill>
-          <a:ln w="6350">
-            <a:solidFill>
-              <a:srgbClr val="E9E6DF"/>
-            </a:solidFill>
-            <a:prstDash val="solid"/>
-          </a:ln>
+            <a:srgbClr val="E9E6DF">
+              <a:alpha val="12000"/>
+            </a:srgbClr>
+          </a:solidFill>
+          <a:ln/>
         </p:spPr>
       </p:sp>
       <p:sp>
@@ -12030,14 +11775,11 @@
             <a:avLst/>
           </a:prstGeom>
           <a:solidFill>
-            <a:srgbClr val="050505"/>
-          </a:solidFill>
-          <a:ln w="6350">
-            <a:solidFill>
-              <a:srgbClr val="E9E6DF"/>
-            </a:solidFill>
-            <a:prstDash val="solid"/>
-          </a:ln>
+            <a:srgbClr val="E9E6DF">
+              <a:alpha val="12000"/>
+            </a:srgbClr>
+          </a:solidFill>
+          <a:ln/>
         </p:spPr>
       </p:sp>
       <p:sp>
@@ -12057,12 +11799,7 @@
           <a:solidFill>
             <a:srgbClr val="E9E6DF"/>
           </a:solidFill>
-          <a:ln w="6350">
-            <a:solidFill>
-              <a:srgbClr val="E9E6DF"/>
-            </a:solidFill>
-            <a:prstDash val="solid"/>
-          </a:ln>
+          <a:ln/>
         </p:spPr>
       </p:sp>
       <p:sp>
@@ -12080,14 +11817,11 @@
             <a:avLst/>
           </a:prstGeom>
           <a:solidFill>
-            <a:srgbClr val="050505"/>
-          </a:solidFill>
-          <a:ln w="6350">
-            <a:solidFill>
-              <a:srgbClr val="E9E6DF"/>
-            </a:solidFill>
-            <a:prstDash val="solid"/>
-          </a:ln>
+            <a:srgbClr val="E9E6DF">
+              <a:alpha val="12000"/>
+            </a:srgbClr>
+          </a:solidFill>
+          <a:ln/>
         </p:spPr>
       </p:sp>
       <p:sp>
@@ -12105,14 +11839,11 @@
             <a:avLst/>
           </a:prstGeom>
           <a:solidFill>
-            <a:srgbClr val="050505"/>
-          </a:solidFill>
-          <a:ln w="6350">
-            <a:solidFill>
-              <a:srgbClr val="E9E6DF"/>
-            </a:solidFill>
-            <a:prstDash val="solid"/>
-          </a:ln>
+            <a:srgbClr val="E9E6DF">
+              <a:alpha val="12000"/>
+            </a:srgbClr>
+          </a:solidFill>
+          <a:ln/>
         </p:spPr>
       </p:sp>
       <p:sp>
@@ -12130,14 +11861,11 @@
             <a:avLst/>
           </a:prstGeom>
           <a:solidFill>
-            <a:srgbClr val="050505"/>
-          </a:solidFill>
-          <a:ln w="6350">
-            <a:solidFill>
-              <a:srgbClr val="E9E6DF"/>
-            </a:solidFill>
-            <a:prstDash val="solid"/>
-          </a:ln>
+            <a:srgbClr val="E9E6DF">
+              <a:alpha val="12000"/>
+            </a:srgbClr>
+          </a:solidFill>
+          <a:ln/>
         </p:spPr>
       </p:sp>
       <p:sp>
@@ -12155,14 +11883,11 @@
             <a:avLst/>
           </a:prstGeom>
           <a:solidFill>
-            <a:srgbClr val="050505"/>
-          </a:solidFill>
-          <a:ln w="6350">
-            <a:solidFill>
-              <a:srgbClr val="E9E6DF"/>
-            </a:solidFill>
-            <a:prstDash val="solid"/>
-          </a:ln>
+            <a:srgbClr val="E9E6DF">
+              <a:alpha val="12000"/>
+            </a:srgbClr>
+          </a:solidFill>
+          <a:ln/>
         </p:spPr>
       </p:sp>
       <p:sp>
@@ -12180,14 +11905,11 @@
             <a:avLst/>
           </a:prstGeom>
           <a:solidFill>
-            <a:srgbClr val="050505"/>
-          </a:solidFill>
-          <a:ln w="6350">
-            <a:solidFill>
-              <a:srgbClr val="E9E6DF"/>
-            </a:solidFill>
-            <a:prstDash val="solid"/>
-          </a:ln>
+            <a:srgbClr val="E9E6DF">
+              <a:alpha val="12000"/>
+            </a:srgbClr>
+          </a:solidFill>
+          <a:ln/>
         </p:spPr>
       </p:sp>
       <p:sp>
@@ -12205,14 +11927,11 @@
             <a:avLst/>
           </a:prstGeom>
           <a:solidFill>
-            <a:srgbClr val="050505"/>
-          </a:solidFill>
-          <a:ln w="6350">
-            <a:solidFill>
-              <a:srgbClr val="E9E6DF"/>
-            </a:solidFill>
-            <a:prstDash val="solid"/>
-          </a:ln>
+            <a:srgbClr val="E9E6DF">
+              <a:alpha val="12000"/>
+            </a:srgbClr>
+          </a:solidFill>
+          <a:ln/>
         </p:spPr>
       </p:sp>
       <p:sp>
@@ -12230,14 +11949,11 @@
             <a:avLst/>
           </a:prstGeom>
           <a:solidFill>
-            <a:srgbClr val="050505"/>
-          </a:solidFill>
-          <a:ln w="6350">
-            <a:solidFill>
-              <a:srgbClr val="E9E6DF"/>
-            </a:solidFill>
-            <a:prstDash val="solid"/>
-          </a:ln>
+            <a:srgbClr val="E9E6DF">
+              <a:alpha val="12000"/>
+            </a:srgbClr>
+          </a:solidFill>
+          <a:ln/>
         </p:spPr>
       </p:sp>
       <p:sp>
@@ -12255,14 +11971,11 @@
             <a:avLst/>
           </a:prstGeom>
           <a:solidFill>
-            <a:srgbClr val="050505"/>
-          </a:solidFill>
-          <a:ln w="6350">
-            <a:solidFill>
-              <a:srgbClr val="E9E6DF"/>
-            </a:solidFill>
-            <a:prstDash val="solid"/>
-          </a:ln>
+            <a:srgbClr val="E9E6DF">
+              <a:alpha val="12000"/>
+            </a:srgbClr>
+          </a:solidFill>
+          <a:ln/>
         </p:spPr>
       </p:sp>
       <p:sp>
@@ -12280,14 +11993,11 @@
             <a:avLst/>
           </a:prstGeom>
           <a:solidFill>
-            <a:srgbClr val="050505"/>
-          </a:solidFill>
-          <a:ln w="6350">
-            <a:solidFill>
-              <a:srgbClr val="E9E6DF"/>
-            </a:solidFill>
-            <a:prstDash val="solid"/>
-          </a:ln>
+            <a:srgbClr val="E9E6DF">
+              <a:alpha val="12000"/>
+            </a:srgbClr>
+          </a:solidFill>
+          <a:ln/>
         </p:spPr>
       </p:sp>
       <p:sp>
@@ -12518,7 +12228,7 @@
                 <a:ea typeface="Courier New" pitchFamily="34" charset="-122"/>
                 <a:cs typeface="Courier New" pitchFamily="34" charset="-120"/>
               </a:rPr>
-              <a:t>MATUA</a:t>
+              <a:t>MATUA / N24</a:t>
             </a:r>
             <a:endParaRPr lang="en-US" sz="700" dirty="0"/>
           </a:p>
@@ -13020,14 +12730,11 @@
             <a:avLst/>
           </a:prstGeom>
           <a:solidFill>
-            <a:srgbClr val="050505"/>
-          </a:solidFill>
-          <a:ln w="6350">
-            <a:solidFill>
-              <a:srgbClr val="3A3A38"/>
-            </a:solidFill>
-            <a:prstDash val="solid"/>
-          </a:ln>
+            <a:srgbClr val="E9E6DF">
+              <a:alpha val="12000"/>
+            </a:srgbClr>
+          </a:solidFill>
+          <a:ln/>
         </p:spPr>
       </p:sp>
       <p:sp>
@@ -13045,14 +12752,11 @@
             <a:avLst/>
           </a:prstGeom>
           <a:solidFill>
-            <a:srgbClr val="050505"/>
-          </a:solidFill>
-          <a:ln w="6350">
-            <a:solidFill>
-              <a:srgbClr val="3A3A38"/>
-            </a:solidFill>
-            <a:prstDash val="solid"/>
-          </a:ln>
+            <a:srgbClr val="E9E6DF">
+              <a:alpha val="12000"/>
+            </a:srgbClr>
+          </a:solidFill>
+          <a:ln/>
         </p:spPr>
       </p:sp>
       <p:sp>
@@ -13070,14 +12774,11 @@
             <a:avLst/>
           </a:prstGeom>
           <a:solidFill>
-            <a:srgbClr val="050505"/>
-          </a:solidFill>
-          <a:ln w="6350">
-            <a:solidFill>
-              <a:srgbClr val="3A3A38"/>
-            </a:solidFill>
-            <a:prstDash val="solid"/>
-          </a:ln>
+            <a:srgbClr val="E9E6DF">
+              <a:alpha val="12000"/>
+            </a:srgbClr>
+          </a:solidFill>
+          <a:ln/>
         </p:spPr>
       </p:sp>
       <p:sp>
@@ -13095,14 +12796,11 @@
             <a:avLst/>
           </a:prstGeom>
           <a:solidFill>
-            <a:srgbClr val="050505"/>
-          </a:solidFill>
-          <a:ln w="6350">
-            <a:solidFill>
-              <a:srgbClr val="3A3A38"/>
-            </a:solidFill>
-            <a:prstDash val="solid"/>
-          </a:ln>
+            <a:srgbClr val="E9E6DF">
+              <a:alpha val="12000"/>
+            </a:srgbClr>
+          </a:solidFill>
+          <a:ln/>
         </p:spPr>
       </p:sp>
       <p:sp>
@@ -13120,14 +12818,11 @@
             <a:avLst/>
           </a:prstGeom>
           <a:solidFill>
-            <a:srgbClr val="050505"/>
-          </a:solidFill>
-          <a:ln w="6350">
-            <a:solidFill>
-              <a:srgbClr val="3A3A38"/>
-            </a:solidFill>
-            <a:prstDash val="solid"/>
-          </a:ln>
+            <a:srgbClr val="E9E6DF">
+              <a:alpha val="12000"/>
+            </a:srgbClr>
+          </a:solidFill>
+          <a:ln/>
         </p:spPr>
       </p:sp>
       <p:sp>
@@ -13145,14 +12840,11 @@
             <a:avLst/>
           </a:prstGeom>
           <a:solidFill>
-            <a:srgbClr val="050505"/>
-          </a:solidFill>
-          <a:ln w="6350">
-            <a:solidFill>
-              <a:srgbClr val="3A3A38"/>
-            </a:solidFill>
-            <a:prstDash val="solid"/>
-          </a:ln>
+            <a:srgbClr val="E9E6DF">
+              <a:alpha val="12000"/>
+            </a:srgbClr>
+          </a:solidFill>
+          <a:ln/>
         </p:spPr>
       </p:sp>
       <p:sp>
@@ -13170,14 +12862,11 @@
             <a:avLst/>
           </a:prstGeom>
           <a:solidFill>
-            <a:srgbClr val="050505"/>
-          </a:solidFill>
-          <a:ln w="6350">
-            <a:solidFill>
-              <a:srgbClr val="3A3A38"/>
-            </a:solidFill>
-            <a:prstDash val="solid"/>
-          </a:ln>
+            <a:srgbClr val="E9E6DF">
+              <a:alpha val="12000"/>
+            </a:srgbClr>
+          </a:solidFill>
+          <a:ln/>
         </p:spPr>
       </p:sp>
       <p:sp>
@@ -13197,12 +12886,7 @@
           <a:solidFill>
             <a:srgbClr val="A8FF3E"/>
           </a:solidFill>
-          <a:ln w="6350">
-            <a:solidFill>
-              <a:srgbClr val="A8FF3E"/>
-            </a:solidFill>
-            <a:prstDash val="solid"/>
-          </a:ln>
+          <a:ln/>
         </p:spPr>
       </p:sp>
       <p:sp>
@@ -13220,14 +12904,11 @@
             <a:avLst/>
           </a:prstGeom>
           <a:solidFill>
-            <a:srgbClr val="050505"/>
-          </a:solidFill>
-          <a:ln w="6350">
-            <a:solidFill>
-              <a:srgbClr val="3A3A38"/>
-            </a:solidFill>
-            <a:prstDash val="solid"/>
-          </a:ln>
+            <a:srgbClr val="E9E6DF">
+              <a:alpha val="12000"/>
+            </a:srgbClr>
+          </a:solidFill>
+          <a:ln/>
         </p:spPr>
       </p:sp>
       <p:sp>
@@ -13245,14 +12926,11 @@
             <a:avLst/>
           </a:prstGeom>
           <a:solidFill>
-            <a:srgbClr val="050505"/>
-          </a:solidFill>
-          <a:ln w="6350">
-            <a:solidFill>
-              <a:srgbClr val="3A3A38"/>
-            </a:solidFill>
-            <a:prstDash val="solid"/>
-          </a:ln>
+            <a:srgbClr val="E9E6DF">
+              <a:alpha val="12000"/>
+            </a:srgbClr>
+          </a:solidFill>
+          <a:ln/>
         </p:spPr>
       </p:sp>
       <p:sp>
@@ -13270,14 +12948,11 @@
             <a:avLst/>
           </a:prstGeom>
           <a:solidFill>
-            <a:srgbClr val="050505"/>
-          </a:solidFill>
-          <a:ln w="6350">
-            <a:solidFill>
-              <a:srgbClr val="3A3A38"/>
-            </a:solidFill>
-            <a:prstDash val="solid"/>
-          </a:ln>
+            <a:srgbClr val="E9E6DF">
+              <a:alpha val="12000"/>
+            </a:srgbClr>
+          </a:solidFill>
+          <a:ln/>
         </p:spPr>
       </p:sp>
       <p:sp>
@@ -13295,14 +12970,11 @@
             <a:avLst/>
           </a:prstGeom>
           <a:solidFill>
-            <a:srgbClr val="050505"/>
-          </a:solidFill>
-          <a:ln w="6350">
-            <a:solidFill>
-              <a:srgbClr val="3A3A38"/>
-            </a:solidFill>
-            <a:prstDash val="solid"/>
-          </a:ln>
+            <a:srgbClr val="E9E6DF">
+              <a:alpha val="12000"/>
+            </a:srgbClr>
+          </a:solidFill>
+          <a:ln/>
         </p:spPr>
       </p:sp>
       <p:sp>
@@ -13320,14 +12992,11 @@
             <a:avLst/>
           </a:prstGeom>
           <a:solidFill>
-            <a:srgbClr val="050505"/>
-          </a:solidFill>
-          <a:ln w="6350">
-            <a:solidFill>
-              <a:srgbClr val="3A3A38"/>
-            </a:solidFill>
-            <a:prstDash val="solid"/>
-          </a:ln>
+            <a:srgbClr val="E9E6DF">
+              <a:alpha val="12000"/>
+            </a:srgbClr>
+          </a:solidFill>
+          <a:ln/>
         </p:spPr>
       </p:sp>
       <p:sp>
@@ -13345,14 +13014,11 @@
             <a:avLst/>
           </a:prstGeom>
           <a:solidFill>
-            <a:srgbClr val="050505"/>
-          </a:solidFill>
-          <a:ln w="6350">
-            <a:solidFill>
-              <a:srgbClr val="3A3A38"/>
-            </a:solidFill>
-            <a:prstDash val="solid"/>
-          </a:ln>
+            <a:srgbClr val="E9E6DF">
+              <a:alpha val="12000"/>
+            </a:srgbClr>
+          </a:solidFill>
+          <a:ln/>
         </p:spPr>
       </p:sp>
       <p:sp>
@@ -13583,7 +13249,7 @@
                 <a:ea typeface="Courier New" pitchFamily="34" charset="-122"/>
                 <a:cs typeface="Courier New" pitchFamily="34" charset="-120"/>
               </a:rPr>
-              <a:t>MATUA</a:t>
+              <a:t>MATUA / N24</a:t>
             </a:r>
             <a:endParaRPr lang="en-US" sz="600" dirty="0"/>
           </a:p>
@@ -14553,14 +14219,11 @@
             <a:avLst/>
           </a:prstGeom>
           <a:solidFill>
-            <a:srgbClr val="050505"/>
-          </a:solidFill>
-          <a:ln w="6350">
-            <a:solidFill>
-              <a:srgbClr val="3A3A38"/>
-            </a:solidFill>
-            <a:prstDash val="solid"/>
-          </a:ln>
+            <a:srgbClr val="E9E6DF">
+              <a:alpha val="12000"/>
+            </a:srgbClr>
+          </a:solidFill>
+          <a:ln/>
         </p:spPr>
       </p:sp>
       <p:sp>
@@ -14578,14 +14241,11 @@
             <a:avLst/>
           </a:prstGeom>
           <a:solidFill>
-            <a:srgbClr val="050505"/>
-          </a:solidFill>
-          <a:ln w="6350">
-            <a:solidFill>
-              <a:srgbClr val="3A3A38"/>
-            </a:solidFill>
-            <a:prstDash val="solid"/>
-          </a:ln>
+            <a:srgbClr val="E9E6DF">
+              <a:alpha val="12000"/>
+            </a:srgbClr>
+          </a:solidFill>
+          <a:ln/>
         </p:spPr>
       </p:sp>
       <p:sp>
@@ -14603,14 +14263,11 @@
             <a:avLst/>
           </a:prstGeom>
           <a:solidFill>
-            <a:srgbClr val="050505"/>
-          </a:solidFill>
-          <a:ln w="6350">
-            <a:solidFill>
-              <a:srgbClr val="3A3A38"/>
-            </a:solidFill>
-            <a:prstDash val="solid"/>
-          </a:ln>
+            <a:srgbClr val="E9E6DF">
+              <a:alpha val="12000"/>
+            </a:srgbClr>
+          </a:solidFill>
+          <a:ln/>
         </p:spPr>
       </p:sp>
       <p:sp>
@@ -14628,14 +14285,11 @@
             <a:avLst/>
           </a:prstGeom>
           <a:solidFill>
-            <a:srgbClr val="050505"/>
-          </a:solidFill>
-          <a:ln w="6350">
-            <a:solidFill>
-              <a:srgbClr val="3A3A38"/>
-            </a:solidFill>
-            <a:prstDash val="solid"/>
-          </a:ln>
+            <a:srgbClr val="E9E6DF">
+              <a:alpha val="12000"/>
+            </a:srgbClr>
+          </a:solidFill>
+          <a:ln/>
         </p:spPr>
       </p:sp>
       <p:sp>
@@ -14653,14 +14307,11 @@
             <a:avLst/>
           </a:prstGeom>
           <a:solidFill>
-            <a:srgbClr val="050505"/>
-          </a:solidFill>
-          <a:ln w="6350">
-            <a:solidFill>
-              <a:srgbClr val="3A3A38"/>
-            </a:solidFill>
-            <a:prstDash val="solid"/>
-          </a:ln>
+            <a:srgbClr val="E9E6DF">
+              <a:alpha val="12000"/>
+            </a:srgbClr>
+          </a:solidFill>
+          <a:ln/>
         </p:spPr>
       </p:sp>
       <p:sp>
@@ -14678,14 +14329,11 @@
             <a:avLst/>
           </a:prstGeom>
           <a:solidFill>
-            <a:srgbClr val="050505"/>
-          </a:solidFill>
-          <a:ln w="6350">
-            <a:solidFill>
-              <a:srgbClr val="3A3A38"/>
-            </a:solidFill>
-            <a:prstDash val="solid"/>
-          </a:ln>
+            <a:srgbClr val="E9E6DF">
+              <a:alpha val="12000"/>
+            </a:srgbClr>
+          </a:solidFill>
+          <a:ln/>
         </p:spPr>
       </p:sp>
       <p:sp>
@@ -14703,14 +14351,11 @@
             <a:avLst/>
           </a:prstGeom>
           <a:solidFill>
-            <a:srgbClr val="050505"/>
-          </a:solidFill>
-          <a:ln w="6350">
-            <a:solidFill>
-              <a:srgbClr val="3A3A38"/>
-            </a:solidFill>
-            <a:prstDash val="solid"/>
-          </a:ln>
+            <a:srgbClr val="E9E6DF">
+              <a:alpha val="12000"/>
+            </a:srgbClr>
+          </a:solidFill>
+          <a:ln/>
         </p:spPr>
       </p:sp>
       <p:sp>
@@ -14728,14 +14373,11 @@
             <a:avLst/>
           </a:prstGeom>
           <a:solidFill>
-            <a:srgbClr val="050505"/>
-          </a:solidFill>
-          <a:ln w="6350">
-            <a:solidFill>
-              <a:srgbClr val="3A3A38"/>
-            </a:solidFill>
-            <a:prstDash val="solid"/>
-          </a:ln>
+            <a:srgbClr val="E9E6DF">
+              <a:alpha val="12000"/>
+            </a:srgbClr>
+          </a:solidFill>
+          <a:ln/>
         </p:spPr>
       </p:sp>
       <p:sp>
@@ -14753,14 +14395,11 @@
             <a:avLst/>
           </a:prstGeom>
           <a:solidFill>
-            <a:srgbClr val="050505"/>
-          </a:solidFill>
-          <a:ln w="6350">
-            <a:solidFill>
-              <a:srgbClr val="3A3A38"/>
-            </a:solidFill>
-            <a:prstDash val="solid"/>
-          </a:ln>
+            <a:srgbClr val="E9E6DF">
+              <a:alpha val="12000"/>
+            </a:srgbClr>
+          </a:solidFill>
+          <a:ln/>
         </p:spPr>
       </p:sp>
       <p:sp>
@@ -14778,14 +14417,11 @@
             <a:avLst/>
           </a:prstGeom>
           <a:solidFill>
-            <a:srgbClr val="050505"/>
-          </a:solidFill>
-          <a:ln w="6350">
-            <a:solidFill>
-              <a:srgbClr val="3A3A38"/>
-            </a:solidFill>
-            <a:prstDash val="solid"/>
-          </a:ln>
+            <a:srgbClr val="E9E6DF">
+              <a:alpha val="12000"/>
+            </a:srgbClr>
+          </a:solidFill>
+          <a:ln/>
         </p:spPr>
       </p:sp>
       <p:sp>
@@ -14805,12 +14441,7 @@
           <a:solidFill>
             <a:srgbClr val="A8FF3E"/>
           </a:solidFill>
-          <a:ln w="6350">
-            <a:solidFill>
-              <a:srgbClr val="A8FF3E"/>
-            </a:solidFill>
-            <a:prstDash val="solid"/>
-          </a:ln>
+          <a:ln/>
         </p:spPr>
       </p:sp>
       <p:sp>
@@ -14830,12 +14461,7 @@
           <a:solidFill>
             <a:srgbClr val="A8FF3E"/>
           </a:solidFill>
-          <a:ln w="6350">
-            <a:solidFill>
-              <a:srgbClr val="A8FF3E"/>
-            </a:solidFill>
-            <a:prstDash val="solid"/>
-          </a:ln>
+          <a:ln/>
         </p:spPr>
       </p:sp>
       <p:sp>
@@ -14853,14 +14479,11 @@
             <a:avLst/>
           </a:prstGeom>
           <a:solidFill>
-            <a:srgbClr val="050505"/>
-          </a:solidFill>
-          <a:ln w="6350">
-            <a:solidFill>
-              <a:srgbClr val="3A3A38"/>
-            </a:solidFill>
-            <a:prstDash val="solid"/>
-          </a:ln>
+            <a:srgbClr val="E9E6DF">
+              <a:alpha val="12000"/>
+            </a:srgbClr>
+          </a:solidFill>
+          <a:ln/>
         </p:spPr>
       </p:sp>
       <p:sp>
@@ -14878,14 +14501,11 @@
             <a:avLst/>
           </a:prstGeom>
           <a:solidFill>
-            <a:srgbClr val="050505"/>
-          </a:solidFill>
-          <a:ln w="6350">
-            <a:solidFill>
-              <a:srgbClr val="3A3A38"/>
-            </a:solidFill>
-            <a:prstDash val="solid"/>
-          </a:ln>
+            <a:srgbClr val="E9E6DF">
+              <a:alpha val="12000"/>
+            </a:srgbClr>
+          </a:solidFill>
+          <a:ln/>
         </p:spPr>
       </p:sp>
       <p:sp>
@@ -15116,7 +14736,7 @@
                 <a:ea typeface="Courier New" pitchFamily="34" charset="-122"/>
                 <a:cs typeface="Courier New" pitchFamily="34" charset="-120"/>
               </a:rPr>
-              <a:t>MATUA</a:t>
+              <a:t>MATUA / N24</a:t>
             </a:r>
             <a:endParaRPr lang="en-US" sz="600" dirty="0"/>
           </a:p>
@@ -16086,14 +15706,11 @@
             <a:avLst/>
           </a:prstGeom>
           <a:solidFill>
-            <a:srgbClr val="050505"/>
-          </a:solidFill>
-          <a:ln w="6350">
-            <a:solidFill>
-              <a:srgbClr val="3A3A38"/>
-            </a:solidFill>
-            <a:prstDash val="solid"/>
-          </a:ln>
+            <a:srgbClr val="E9E6DF">
+              <a:alpha val="12000"/>
+            </a:srgbClr>
+          </a:solidFill>
+          <a:ln/>
         </p:spPr>
       </p:sp>
       <p:sp>
@@ -16111,14 +15728,11 @@
             <a:avLst/>
           </a:prstGeom>
           <a:solidFill>
-            <a:srgbClr val="050505"/>
-          </a:solidFill>
-          <a:ln w="6350">
-            <a:solidFill>
-              <a:srgbClr val="3A3A38"/>
-            </a:solidFill>
-            <a:prstDash val="solid"/>
-          </a:ln>
+            <a:srgbClr val="E9E6DF">
+              <a:alpha val="12000"/>
+            </a:srgbClr>
+          </a:solidFill>
+          <a:ln/>
         </p:spPr>
       </p:sp>
       <p:sp>
@@ -16136,14 +15750,11 @@
             <a:avLst/>
           </a:prstGeom>
           <a:solidFill>
-            <a:srgbClr val="050505"/>
-          </a:solidFill>
-          <a:ln w="6350">
-            <a:solidFill>
-              <a:srgbClr val="3A3A38"/>
-            </a:solidFill>
-            <a:prstDash val="solid"/>
-          </a:ln>
+            <a:srgbClr val="E9E6DF">
+              <a:alpha val="12000"/>
+            </a:srgbClr>
+          </a:solidFill>
+          <a:ln/>
         </p:spPr>
       </p:sp>
       <p:sp>
@@ -16161,14 +15772,11 @@
             <a:avLst/>
           </a:prstGeom>
           <a:solidFill>
-            <a:srgbClr val="050505"/>
-          </a:solidFill>
-          <a:ln w="6350">
-            <a:solidFill>
-              <a:srgbClr val="3A3A38"/>
-            </a:solidFill>
-            <a:prstDash val="solid"/>
-          </a:ln>
+            <a:srgbClr val="E9E6DF">
+              <a:alpha val="12000"/>
+            </a:srgbClr>
+          </a:solidFill>
+          <a:ln/>
         </p:spPr>
       </p:sp>
       <p:sp>
@@ -16186,14 +15794,11 @@
             <a:avLst/>
           </a:prstGeom>
           <a:solidFill>
-            <a:srgbClr val="050505"/>
-          </a:solidFill>
-          <a:ln w="6350">
-            <a:solidFill>
-              <a:srgbClr val="3A3A38"/>
-            </a:solidFill>
-            <a:prstDash val="solid"/>
-          </a:ln>
+            <a:srgbClr val="E9E6DF">
+              <a:alpha val="12000"/>
+            </a:srgbClr>
+          </a:solidFill>
+          <a:ln/>
         </p:spPr>
       </p:sp>
       <p:sp>
@@ -16211,14 +15816,11 @@
             <a:avLst/>
           </a:prstGeom>
           <a:solidFill>
-            <a:srgbClr val="050505"/>
-          </a:solidFill>
-          <a:ln w="6350">
-            <a:solidFill>
-              <a:srgbClr val="3A3A38"/>
-            </a:solidFill>
-            <a:prstDash val="solid"/>
-          </a:ln>
+            <a:srgbClr val="E9E6DF">
+              <a:alpha val="12000"/>
+            </a:srgbClr>
+          </a:solidFill>
+          <a:ln/>
         </p:spPr>
       </p:sp>
       <p:sp>
@@ -16236,14 +15838,11 @@
             <a:avLst/>
           </a:prstGeom>
           <a:solidFill>
-            <a:srgbClr val="050505"/>
-          </a:solidFill>
-          <a:ln w="6350">
-            <a:solidFill>
-              <a:srgbClr val="3A3A38"/>
-            </a:solidFill>
-            <a:prstDash val="solid"/>
-          </a:ln>
+            <a:srgbClr val="E9E6DF">
+              <a:alpha val="12000"/>
+            </a:srgbClr>
+          </a:solidFill>
+          <a:ln/>
         </p:spPr>
       </p:sp>
       <p:sp>
@@ -16261,14 +15860,11 @@
             <a:avLst/>
           </a:prstGeom>
           <a:solidFill>
-            <a:srgbClr val="050505"/>
-          </a:solidFill>
-          <a:ln w="6350">
-            <a:solidFill>
-              <a:srgbClr val="3A3A38"/>
-            </a:solidFill>
-            <a:prstDash val="solid"/>
-          </a:ln>
+            <a:srgbClr val="E9E6DF">
+              <a:alpha val="12000"/>
+            </a:srgbClr>
+          </a:solidFill>
+          <a:ln/>
         </p:spPr>
       </p:sp>
       <p:sp>
@@ -16288,12 +15884,7 @@
           <a:solidFill>
             <a:srgbClr val="A8FF3E"/>
           </a:solidFill>
-          <a:ln w="6350">
-            <a:solidFill>
-              <a:srgbClr val="A8FF3E"/>
-            </a:solidFill>
-            <a:prstDash val="solid"/>
-          </a:ln>
+          <a:ln/>
         </p:spPr>
       </p:sp>
       <p:sp>
@@ -16313,12 +15904,7 @@
           <a:solidFill>
             <a:srgbClr val="A8FF3E"/>
           </a:solidFill>
-          <a:ln w="6350">
-            <a:solidFill>
-              <a:srgbClr val="A8FF3E"/>
-            </a:solidFill>
-            <a:prstDash val="solid"/>
-          </a:ln>
+          <a:ln/>
         </p:spPr>
       </p:sp>
       <p:sp>
@@ -16336,14 +15922,11 @@
             <a:avLst/>
           </a:prstGeom>
           <a:solidFill>
-            <a:srgbClr val="050505"/>
-          </a:solidFill>
-          <a:ln w="6350">
-            <a:solidFill>
-              <a:srgbClr val="3A3A38"/>
-            </a:solidFill>
-            <a:prstDash val="solid"/>
-          </a:ln>
+            <a:srgbClr val="E9E6DF">
+              <a:alpha val="12000"/>
+            </a:srgbClr>
+          </a:solidFill>
+          <a:ln/>
         </p:spPr>
       </p:sp>
       <p:sp>
@@ -16361,14 +15944,11 @@
             <a:avLst/>
           </a:prstGeom>
           <a:solidFill>
-            <a:srgbClr val="050505"/>
-          </a:solidFill>
-          <a:ln w="6350">
-            <a:solidFill>
-              <a:srgbClr val="3A3A38"/>
-            </a:solidFill>
-            <a:prstDash val="solid"/>
-          </a:ln>
+            <a:srgbClr val="E9E6DF">
+              <a:alpha val="12000"/>
+            </a:srgbClr>
+          </a:solidFill>
+          <a:ln/>
         </p:spPr>
       </p:sp>
       <p:sp>
@@ -16386,14 +15966,11 @@
             <a:avLst/>
           </a:prstGeom>
           <a:solidFill>
-            <a:srgbClr val="050505"/>
-          </a:solidFill>
-          <a:ln w="6350">
-            <a:solidFill>
-              <a:srgbClr val="3A3A38"/>
-            </a:solidFill>
-            <a:prstDash val="solid"/>
-          </a:ln>
+            <a:srgbClr val="E9E6DF">
+              <a:alpha val="12000"/>
+            </a:srgbClr>
+          </a:solidFill>
+          <a:ln/>
         </p:spPr>
       </p:sp>
       <p:sp>
@@ -16411,14 +15988,11 @@
             <a:avLst/>
           </a:prstGeom>
           <a:solidFill>
-            <a:srgbClr val="050505"/>
-          </a:solidFill>
-          <a:ln w="6350">
-            <a:solidFill>
-              <a:srgbClr val="3A3A38"/>
-            </a:solidFill>
-            <a:prstDash val="solid"/>
-          </a:ln>
+            <a:srgbClr val="E9E6DF">
+              <a:alpha val="12000"/>
+            </a:srgbClr>
+          </a:solidFill>
+          <a:ln/>
         </p:spPr>
       </p:sp>
       <p:sp>
@@ -16649,7 +16223,7 @@
                 <a:ea typeface="Courier New" pitchFamily="34" charset="-122"/>
                 <a:cs typeface="Courier New" pitchFamily="34" charset="-120"/>
               </a:rPr>
-              <a:t>MATUA</a:t>
+              <a:t>MATUA / N24</a:t>
             </a:r>
             <a:endParaRPr lang="en-US" sz="600" dirty="0"/>
           </a:p>
@@ -17619,14 +17193,11 @@
             <a:avLst/>
           </a:prstGeom>
           <a:solidFill>
-            <a:srgbClr val="050505"/>
-          </a:solidFill>
-          <a:ln w="6350">
-            <a:solidFill>
-              <a:srgbClr val="3A3A38"/>
-            </a:solidFill>
-            <a:prstDash val="solid"/>
-          </a:ln>
+            <a:srgbClr val="E9E6DF">
+              <a:alpha val="12000"/>
+            </a:srgbClr>
+          </a:solidFill>
+          <a:ln/>
         </p:spPr>
       </p:sp>
       <p:sp>
@@ -17644,14 +17215,11 @@
             <a:avLst/>
           </a:prstGeom>
           <a:solidFill>
-            <a:srgbClr val="050505"/>
-          </a:solidFill>
-          <a:ln w="6350">
-            <a:solidFill>
-              <a:srgbClr val="3A3A38"/>
-            </a:solidFill>
-            <a:prstDash val="solid"/>
-          </a:ln>
+            <a:srgbClr val="E9E6DF">
+              <a:alpha val="12000"/>
+            </a:srgbClr>
+          </a:solidFill>
+          <a:ln/>
         </p:spPr>
       </p:sp>
       <p:sp>
@@ -17669,14 +17237,11 @@
             <a:avLst/>
           </a:prstGeom>
           <a:solidFill>
-            <a:srgbClr val="050505"/>
-          </a:solidFill>
-          <a:ln w="6350">
-            <a:solidFill>
-              <a:srgbClr val="3A3A38"/>
-            </a:solidFill>
-            <a:prstDash val="solid"/>
-          </a:ln>
+            <a:srgbClr val="E9E6DF">
+              <a:alpha val="12000"/>
+            </a:srgbClr>
+          </a:solidFill>
+          <a:ln/>
         </p:spPr>
       </p:sp>
       <p:sp>
@@ -17694,14 +17259,11 @@
             <a:avLst/>
           </a:prstGeom>
           <a:solidFill>
-            <a:srgbClr val="050505"/>
-          </a:solidFill>
-          <a:ln w="6350">
-            <a:solidFill>
-              <a:srgbClr val="3A3A38"/>
-            </a:solidFill>
-            <a:prstDash val="solid"/>
-          </a:ln>
+            <a:srgbClr val="E9E6DF">
+              <a:alpha val="12000"/>
+            </a:srgbClr>
+          </a:solidFill>
+          <a:ln/>
         </p:spPr>
       </p:sp>
       <p:sp>
@@ -17719,14 +17281,11 @@
             <a:avLst/>
           </a:prstGeom>
           <a:solidFill>
-            <a:srgbClr val="050505"/>
-          </a:solidFill>
-          <a:ln w="6350">
-            <a:solidFill>
-              <a:srgbClr val="3A3A38"/>
-            </a:solidFill>
-            <a:prstDash val="solid"/>
-          </a:ln>
+            <a:srgbClr val="E9E6DF">
+              <a:alpha val="12000"/>
+            </a:srgbClr>
+          </a:solidFill>
+          <a:ln/>
         </p:spPr>
       </p:sp>
       <p:sp>
@@ -17744,14 +17303,11 @@
             <a:avLst/>
           </a:prstGeom>
           <a:solidFill>
-            <a:srgbClr val="050505"/>
-          </a:solidFill>
-          <a:ln w="6350">
-            <a:solidFill>
-              <a:srgbClr val="3A3A38"/>
-            </a:solidFill>
-            <a:prstDash val="solid"/>
-          </a:ln>
+            <a:srgbClr val="E9E6DF">
+              <a:alpha val="12000"/>
+            </a:srgbClr>
+          </a:solidFill>
+          <a:ln/>
         </p:spPr>
       </p:sp>
       <p:sp>
@@ -17769,14 +17325,11 @@
             <a:avLst/>
           </a:prstGeom>
           <a:solidFill>
-            <a:srgbClr val="050505"/>
-          </a:solidFill>
-          <a:ln w="6350">
-            <a:solidFill>
-              <a:srgbClr val="3A3A38"/>
-            </a:solidFill>
-            <a:prstDash val="solid"/>
-          </a:ln>
+            <a:srgbClr val="E9E6DF">
+              <a:alpha val="12000"/>
+            </a:srgbClr>
+          </a:solidFill>
+          <a:ln/>
         </p:spPr>
       </p:sp>
       <p:sp>
@@ -17794,14 +17347,11 @@
             <a:avLst/>
           </a:prstGeom>
           <a:solidFill>
-            <a:srgbClr val="050505"/>
-          </a:solidFill>
-          <a:ln w="6350">
-            <a:solidFill>
-              <a:srgbClr val="3A3A38"/>
-            </a:solidFill>
-            <a:prstDash val="solid"/>
-          </a:ln>
+            <a:srgbClr val="E9E6DF">
+              <a:alpha val="12000"/>
+            </a:srgbClr>
+          </a:solidFill>
+          <a:ln/>
         </p:spPr>
       </p:sp>
       <p:sp>
@@ -17819,14 +17369,11 @@
             <a:avLst/>
           </a:prstGeom>
           <a:solidFill>
-            <a:srgbClr val="050505"/>
-          </a:solidFill>
-          <a:ln w="6350">
-            <a:solidFill>
-              <a:srgbClr val="3A3A38"/>
-            </a:solidFill>
-            <a:prstDash val="solid"/>
-          </a:ln>
+            <a:srgbClr val="E9E6DF">
+              <a:alpha val="12000"/>
+            </a:srgbClr>
+          </a:solidFill>
+          <a:ln/>
         </p:spPr>
       </p:sp>
       <p:sp>
@@ -17844,14 +17391,11 @@
             <a:avLst/>
           </a:prstGeom>
           <a:solidFill>
-            <a:srgbClr val="050505"/>
-          </a:solidFill>
-          <a:ln w="6350">
-            <a:solidFill>
-              <a:srgbClr val="3A3A38"/>
-            </a:solidFill>
-            <a:prstDash val="solid"/>
-          </a:ln>
+            <a:srgbClr val="E9E6DF">
+              <a:alpha val="12000"/>
+            </a:srgbClr>
+          </a:solidFill>
+          <a:ln/>
         </p:spPr>
       </p:sp>
       <p:sp>
@@ -17869,14 +17413,11 @@
             <a:avLst/>
           </a:prstGeom>
           <a:solidFill>
-            <a:srgbClr val="050505"/>
-          </a:solidFill>
-          <a:ln w="6350">
-            <a:solidFill>
-              <a:srgbClr val="3A3A38"/>
-            </a:solidFill>
-            <a:prstDash val="solid"/>
-          </a:ln>
+            <a:srgbClr val="E9E6DF">
+              <a:alpha val="12000"/>
+            </a:srgbClr>
+          </a:solidFill>
+          <a:ln/>
         </p:spPr>
       </p:sp>
       <p:sp>
@@ -17894,14 +17435,11 @@
             <a:avLst/>
           </a:prstGeom>
           <a:solidFill>
-            <a:srgbClr val="050505"/>
-          </a:solidFill>
-          <a:ln w="6350">
-            <a:solidFill>
-              <a:srgbClr val="3A3A38"/>
-            </a:solidFill>
-            <a:prstDash val="solid"/>
-          </a:ln>
+            <a:srgbClr val="E9E6DF">
+              <a:alpha val="12000"/>
+            </a:srgbClr>
+          </a:solidFill>
+          <a:ln/>
         </p:spPr>
       </p:sp>
       <p:sp>
@@ -17919,14 +17457,11 @@
             <a:avLst/>
           </a:prstGeom>
           <a:solidFill>
-            <a:srgbClr val="050505"/>
-          </a:solidFill>
-          <a:ln w="6350">
-            <a:solidFill>
-              <a:srgbClr val="3A3A38"/>
-            </a:solidFill>
-            <a:prstDash val="solid"/>
-          </a:ln>
+            <a:srgbClr val="E9E6DF">
+              <a:alpha val="12000"/>
+            </a:srgbClr>
+          </a:solidFill>
+          <a:ln/>
         </p:spPr>
       </p:sp>
       <p:sp>
@@ -17946,12 +17481,7 @@
           <a:solidFill>
             <a:srgbClr val="A8FF3E"/>
           </a:solidFill>
-          <a:ln w="6350">
-            <a:solidFill>
-              <a:srgbClr val="A8FF3E"/>
-            </a:solidFill>
-            <a:prstDash val="solid"/>
-          </a:ln>
+          <a:ln/>
         </p:spPr>
       </p:sp>
       <p:sp>
@@ -18182,7 +17712,7 @@
                 <a:ea typeface="Courier New" pitchFamily="34" charset="-122"/>
                 <a:cs typeface="Courier New" pitchFamily="34" charset="-120"/>
               </a:rPr>
-              <a:t>MATUA</a:t>
+              <a:t>MATUA / N24</a:t>
             </a:r>
             <a:endParaRPr lang="en-US" sz="600" dirty="0"/>
           </a:p>
@@ -19152,14 +18682,11 @@
             <a:avLst/>
           </a:prstGeom>
           <a:solidFill>
-            <a:srgbClr val="050505"/>
-          </a:solidFill>
-          <a:ln w="6350">
-            <a:solidFill>
-              <a:srgbClr val="3A3A38"/>
-            </a:solidFill>
-            <a:prstDash val="solid"/>
-          </a:ln>
+            <a:srgbClr val="E9E6DF">
+              <a:alpha val="12000"/>
+            </a:srgbClr>
+          </a:solidFill>
+          <a:ln/>
         </p:spPr>
       </p:sp>
       <p:sp>
@@ -19177,14 +18704,11 @@
             <a:avLst/>
           </a:prstGeom>
           <a:solidFill>
-            <a:srgbClr val="050505"/>
-          </a:solidFill>
-          <a:ln w="6350">
-            <a:solidFill>
-              <a:srgbClr val="3A3A38"/>
-            </a:solidFill>
-            <a:prstDash val="solid"/>
-          </a:ln>
+            <a:srgbClr val="E9E6DF">
+              <a:alpha val="12000"/>
+            </a:srgbClr>
+          </a:solidFill>
+          <a:ln/>
         </p:spPr>
       </p:sp>
       <p:sp>
@@ -19202,14 +18726,11 @@
             <a:avLst/>
           </a:prstGeom>
           <a:solidFill>
-            <a:srgbClr val="050505"/>
-          </a:solidFill>
-          <a:ln w="6350">
-            <a:solidFill>
-              <a:srgbClr val="3A3A38"/>
-            </a:solidFill>
-            <a:prstDash val="solid"/>
-          </a:ln>
+            <a:srgbClr val="E9E6DF">
+              <a:alpha val="12000"/>
+            </a:srgbClr>
+          </a:solidFill>
+          <a:ln/>
         </p:spPr>
       </p:sp>
       <p:sp>
@@ -19227,14 +18748,11 @@
             <a:avLst/>
           </a:prstGeom>
           <a:solidFill>
-            <a:srgbClr val="050505"/>
-          </a:solidFill>
-          <a:ln w="6350">
-            <a:solidFill>
-              <a:srgbClr val="3A3A38"/>
-            </a:solidFill>
-            <a:prstDash val="solid"/>
-          </a:ln>
+            <a:srgbClr val="E9E6DF">
+              <a:alpha val="12000"/>
+            </a:srgbClr>
+          </a:solidFill>
+          <a:ln/>
         </p:spPr>
       </p:sp>
       <p:sp>
@@ -19252,14 +18770,11 @@
             <a:avLst/>
           </a:prstGeom>
           <a:solidFill>
-            <a:srgbClr val="050505"/>
-          </a:solidFill>
-          <a:ln w="6350">
-            <a:solidFill>
-              <a:srgbClr val="3A3A38"/>
-            </a:solidFill>
-            <a:prstDash val="solid"/>
-          </a:ln>
+            <a:srgbClr val="E9E6DF">
+              <a:alpha val="12000"/>
+            </a:srgbClr>
+          </a:solidFill>
+          <a:ln/>
         </p:spPr>
       </p:sp>
       <p:sp>
@@ -19277,14 +18792,11 @@
             <a:avLst/>
           </a:prstGeom>
           <a:solidFill>
-            <a:srgbClr val="050505"/>
-          </a:solidFill>
-          <a:ln w="6350">
-            <a:solidFill>
-              <a:srgbClr val="3A3A38"/>
-            </a:solidFill>
-            <a:prstDash val="solid"/>
-          </a:ln>
+            <a:srgbClr val="E9E6DF">
+              <a:alpha val="12000"/>
+            </a:srgbClr>
+          </a:solidFill>
+          <a:ln/>
         </p:spPr>
       </p:sp>
       <p:sp>
@@ -19302,14 +18814,11 @@
             <a:avLst/>
           </a:prstGeom>
           <a:solidFill>
-            <a:srgbClr val="050505"/>
-          </a:solidFill>
-          <a:ln w="6350">
-            <a:solidFill>
-              <a:srgbClr val="3A3A38"/>
-            </a:solidFill>
-            <a:prstDash val="solid"/>
-          </a:ln>
+            <a:srgbClr val="E9E6DF">
+              <a:alpha val="12000"/>
+            </a:srgbClr>
+          </a:solidFill>
+          <a:ln/>
         </p:spPr>
       </p:sp>
       <p:sp>
@@ -19327,14 +18836,11 @@
             <a:avLst/>
           </a:prstGeom>
           <a:solidFill>
-            <a:srgbClr val="050505"/>
-          </a:solidFill>
-          <a:ln w="6350">
-            <a:solidFill>
-              <a:srgbClr val="3A3A38"/>
-            </a:solidFill>
-            <a:prstDash val="solid"/>
-          </a:ln>
+            <a:srgbClr val="E9E6DF">
+              <a:alpha val="12000"/>
+            </a:srgbClr>
+          </a:solidFill>
+          <a:ln/>
         </p:spPr>
       </p:sp>
       <p:sp>
@@ -19352,14 +18858,11 @@
             <a:avLst/>
           </a:prstGeom>
           <a:solidFill>
-            <a:srgbClr val="050505"/>
-          </a:solidFill>
-          <a:ln w="6350">
-            <a:solidFill>
-              <a:srgbClr val="3A3A38"/>
-            </a:solidFill>
-            <a:prstDash val="solid"/>
-          </a:ln>
+            <a:srgbClr val="E9E6DF">
+              <a:alpha val="12000"/>
+            </a:srgbClr>
+          </a:solidFill>
+          <a:ln/>
         </p:spPr>
       </p:sp>
       <p:sp>
@@ -19377,14 +18880,11 @@
             <a:avLst/>
           </a:prstGeom>
           <a:solidFill>
-            <a:srgbClr val="050505"/>
-          </a:solidFill>
-          <a:ln w="6350">
-            <a:solidFill>
-              <a:srgbClr val="3A3A38"/>
-            </a:solidFill>
-            <a:prstDash val="solid"/>
-          </a:ln>
+            <a:srgbClr val="E9E6DF">
+              <a:alpha val="12000"/>
+            </a:srgbClr>
+          </a:solidFill>
+          <a:ln/>
         </p:spPr>
       </p:sp>
       <p:sp>
@@ -19402,14 +18902,11 @@
             <a:avLst/>
           </a:prstGeom>
           <a:solidFill>
-            <a:srgbClr val="050505"/>
-          </a:solidFill>
-          <a:ln w="6350">
-            <a:solidFill>
-              <a:srgbClr val="3A3A38"/>
-            </a:solidFill>
-            <a:prstDash val="solid"/>
-          </a:ln>
+            <a:srgbClr val="E9E6DF">
+              <a:alpha val="12000"/>
+            </a:srgbClr>
+          </a:solidFill>
+          <a:ln/>
         </p:spPr>
       </p:sp>
       <p:sp>
@@ -19427,14 +18924,11 @@
             <a:avLst/>
           </a:prstGeom>
           <a:solidFill>
-            <a:srgbClr val="050505"/>
-          </a:solidFill>
-          <a:ln w="6350">
-            <a:solidFill>
-              <a:srgbClr val="3A3A38"/>
-            </a:solidFill>
-            <a:prstDash val="solid"/>
-          </a:ln>
+            <a:srgbClr val="E9E6DF">
+              <a:alpha val="12000"/>
+            </a:srgbClr>
+          </a:solidFill>
+          <a:ln/>
         </p:spPr>
       </p:sp>
       <p:sp>
@@ -19454,12 +18948,7 @@
           <a:solidFill>
             <a:srgbClr val="A8FF3E"/>
           </a:solidFill>
-          <a:ln w="6350">
-            <a:solidFill>
-              <a:srgbClr val="A8FF3E"/>
-            </a:solidFill>
-            <a:prstDash val="solid"/>
-          </a:ln>
+          <a:ln/>
         </p:spPr>
       </p:sp>
       <p:sp>
@@ -19477,14 +18966,11 @@
             <a:avLst/>
           </a:prstGeom>
           <a:solidFill>
-            <a:srgbClr val="050505"/>
-          </a:solidFill>
-          <a:ln w="6350">
-            <a:solidFill>
-              <a:srgbClr val="3A3A38"/>
-            </a:solidFill>
-            <a:prstDash val="solid"/>
-          </a:ln>
+            <a:srgbClr val="E9E6DF">
+              <a:alpha val="12000"/>
+            </a:srgbClr>
+          </a:solidFill>
+          <a:ln/>
         </p:spPr>
       </p:sp>
       <p:sp>
@@ -19715,7 +19201,7 @@
                 <a:ea typeface="Courier New" pitchFamily="34" charset="-122"/>
                 <a:cs typeface="Courier New" pitchFamily="34" charset="-120"/>
               </a:rPr>
-              <a:t>MATUA</a:t>
+              <a:t>MATUA / N24</a:t>
             </a:r>
             <a:endParaRPr lang="en-US" sz="600" dirty="0"/>
           </a:p>
@@ -20685,14 +20171,11 @@
             <a:avLst/>
           </a:prstGeom>
           <a:solidFill>
-            <a:srgbClr val="050505"/>
-          </a:solidFill>
-          <a:ln w="6350">
-            <a:solidFill>
-              <a:srgbClr val="3A3A38"/>
-            </a:solidFill>
-            <a:prstDash val="solid"/>
-          </a:ln>
+            <a:srgbClr val="E9E6DF">
+              <a:alpha val="12000"/>
+            </a:srgbClr>
+          </a:solidFill>
+          <a:ln/>
         </p:spPr>
       </p:sp>
       <p:sp>
@@ -20710,14 +20193,11 @@
             <a:avLst/>
           </a:prstGeom>
           <a:solidFill>
-            <a:srgbClr val="050505"/>
-          </a:solidFill>
-          <a:ln w="6350">
-            <a:solidFill>
-              <a:srgbClr val="3A3A38"/>
-            </a:solidFill>
-            <a:prstDash val="solid"/>
-          </a:ln>
+            <a:srgbClr val="E9E6DF">
+              <a:alpha val="12000"/>
+            </a:srgbClr>
+          </a:solidFill>
+          <a:ln/>
         </p:spPr>
       </p:sp>
       <p:sp>
@@ -20735,14 +20215,11 @@
             <a:avLst/>
           </a:prstGeom>
           <a:solidFill>
-            <a:srgbClr val="050505"/>
-          </a:solidFill>
-          <a:ln w="6350">
-            <a:solidFill>
-              <a:srgbClr val="3A3A38"/>
-            </a:solidFill>
-            <a:prstDash val="solid"/>
-          </a:ln>
+            <a:srgbClr val="E9E6DF">
+              <a:alpha val="12000"/>
+            </a:srgbClr>
+          </a:solidFill>
+          <a:ln/>
         </p:spPr>
       </p:sp>
       <p:sp>
@@ -20760,14 +20237,11 @@
             <a:avLst/>
           </a:prstGeom>
           <a:solidFill>
-            <a:srgbClr val="050505"/>
-          </a:solidFill>
-          <a:ln w="6350">
-            <a:solidFill>
-              <a:srgbClr val="3A3A38"/>
-            </a:solidFill>
-            <a:prstDash val="solid"/>
-          </a:ln>
+            <a:srgbClr val="E9E6DF">
+              <a:alpha val="12000"/>
+            </a:srgbClr>
+          </a:solidFill>
+          <a:ln/>
         </p:spPr>
       </p:sp>
       <p:sp>
@@ -20785,14 +20259,11 @@
             <a:avLst/>
           </a:prstGeom>
           <a:solidFill>
-            <a:srgbClr val="050505"/>
-          </a:solidFill>
-          <a:ln w="6350">
-            <a:solidFill>
-              <a:srgbClr val="3A3A38"/>
-            </a:solidFill>
-            <a:prstDash val="solid"/>
-          </a:ln>
+            <a:srgbClr val="E9E6DF">
+              <a:alpha val="12000"/>
+            </a:srgbClr>
+          </a:solidFill>
+          <a:ln/>
         </p:spPr>
       </p:sp>
       <p:sp>
@@ -20812,12 +20283,7 @@
           <a:solidFill>
             <a:srgbClr val="A8FF3E"/>
           </a:solidFill>
-          <a:ln w="6350">
-            <a:solidFill>
-              <a:srgbClr val="A8FF3E"/>
-            </a:solidFill>
-            <a:prstDash val="solid"/>
-          </a:ln>
+          <a:ln/>
         </p:spPr>
       </p:sp>
       <p:sp>
@@ -20837,12 +20303,7 @@
           <a:solidFill>
             <a:srgbClr val="A8FF3E"/>
           </a:solidFill>
-          <a:ln w="6350">
-            <a:solidFill>
-              <a:srgbClr val="A8FF3E"/>
-            </a:solidFill>
-            <a:prstDash val="solid"/>
-          </a:ln>
+          <a:ln/>
         </p:spPr>
       </p:sp>
       <p:sp>
@@ -20860,14 +20321,11 @@
             <a:avLst/>
           </a:prstGeom>
           <a:solidFill>
-            <a:srgbClr val="050505"/>
-          </a:solidFill>
-          <a:ln w="6350">
-            <a:solidFill>
-              <a:srgbClr val="3A3A38"/>
-            </a:solidFill>
-            <a:prstDash val="solid"/>
-          </a:ln>
+            <a:srgbClr val="E9E6DF">
+              <a:alpha val="12000"/>
+            </a:srgbClr>
+          </a:solidFill>
+          <a:ln/>
         </p:spPr>
       </p:sp>
       <p:sp>
@@ -20885,14 +20343,11 @@
             <a:avLst/>
           </a:prstGeom>
           <a:solidFill>
-            <a:srgbClr val="050505"/>
-          </a:solidFill>
-          <a:ln w="6350">
-            <a:solidFill>
-              <a:srgbClr val="3A3A38"/>
-            </a:solidFill>
-            <a:prstDash val="solid"/>
-          </a:ln>
+            <a:srgbClr val="E9E6DF">
+              <a:alpha val="12000"/>
+            </a:srgbClr>
+          </a:solidFill>
+          <a:ln/>
         </p:spPr>
       </p:sp>
       <p:sp>
@@ -20910,14 +20365,11 @@
             <a:avLst/>
           </a:prstGeom>
           <a:solidFill>
-            <a:srgbClr val="050505"/>
-          </a:solidFill>
-          <a:ln w="6350">
-            <a:solidFill>
-              <a:srgbClr val="3A3A38"/>
-            </a:solidFill>
-            <a:prstDash val="solid"/>
-          </a:ln>
+            <a:srgbClr val="E9E6DF">
+              <a:alpha val="12000"/>
+            </a:srgbClr>
+          </a:solidFill>
+          <a:ln/>
         </p:spPr>
       </p:sp>
       <p:sp>
@@ -20935,14 +20387,11 @@
             <a:avLst/>
           </a:prstGeom>
           <a:solidFill>
-            <a:srgbClr val="050505"/>
-          </a:solidFill>
-          <a:ln w="6350">
-            <a:solidFill>
-              <a:srgbClr val="3A3A38"/>
-            </a:solidFill>
-            <a:prstDash val="solid"/>
-          </a:ln>
+            <a:srgbClr val="E9E6DF">
+              <a:alpha val="12000"/>
+            </a:srgbClr>
+          </a:solidFill>
+          <a:ln/>
         </p:spPr>
       </p:sp>
       <p:sp>
@@ -20960,14 +20409,11 @@
             <a:avLst/>
           </a:prstGeom>
           <a:solidFill>
-            <a:srgbClr val="050505"/>
-          </a:solidFill>
-          <a:ln w="6350">
-            <a:solidFill>
-              <a:srgbClr val="3A3A38"/>
-            </a:solidFill>
-            <a:prstDash val="solid"/>
-          </a:ln>
+            <a:srgbClr val="E9E6DF">
+              <a:alpha val="12000"/>
+            </a:srgbClr>
+          </a:solidFill>
+          <a:ln/>
         </p:spPr>
       </p:sp>
       <p:sp>
@@ -20985,14 +20431,11 @@
             <a:avLst/>
           </a:prstGeom>
           <a:solidFill>
-            <a:srgbClr val="050505"/>
-          </a:solidFill>
-          <a:ln w="6350">
-            <a:solidFill>
-              <a:srgbClr val="3A3A38"/>
-            </a:solidFill>
-            <a:prstDash val="solid"/>
-          </a:ln>
+            <a:srgbClr val="E9E6DF">
+              <a:alpha val="12000"/>
+            </a:srgbClr>
+          </a:solidFill>
+          <a:ln/>
         </p:spPr>
       </p:sp>
       <p:sp>
@@ -21010,14 +20453,11 @@
             <a:avLst/>
           </a:prstGeom>
           <a:solidFill>
-            <a:srgbClr val="050505"/>
-          </a:solidFill>
-          <a:ln w="6350">
-            <a:solidFill>
-              <a:srgbClr val="3A3A38"/>
-            </a:solidFill>
-            <a:prstDash val="solid"/>
-          </a:ln>
+            <a:srgbClr val="E9E6DF">
+              <a:alpha val="12000"/>
+            </a:srgbClr>
+          </a:solidFill>
+          <a:ln/>
         </p:spPr>
       </p:sp>
       <p:sp>
@@ -21248,7 +20688,7 @@
                 <a:ea typeface="Courier New" pitchFamily="34" charset="-122"/>
                 <a:cs typeface="Courier New" pitchFamily="34" charset="-120"/>
               </a:rPr>
-              <a:t>MATUA</a:t>
+              <a:t>MATUA / N24</a:t>
             </a:r>
             <a:endParaRPr lang="en-US" sz="600" dirty="0"/>
           </a:p>

</xml_diff>

<commit_message>
postmortem deck: neutralise two slide-5 statements
Rephrase SIR item to focus on data gap (attrition not captured),
not disenfranchisement framing. Rephrase identity-frame item to
political consolidation language, drop religio-cultural characterisation.

Co-Authored-By: Claude Sonnet 4.6 <noreply@anthropic.com>
</commit_message>
<xml_diff>
--- a/engineering/wb_2026_postmortem_deck.pptx
+++ b/engineering/wb_2026_postmortem_deck.pptx
@@ -4776,7 +4776,7 @@
                 <a:ea typeface="Arial Narrow" pitchFamily="34" charset="-122"/>
                 <a:cs typeface="Arial Narrow" pitchFamily="34" charset="-120"/>
               </a:rPr>
-              <a:t>SIR voter-roll deletions — structural disenfranchisement.</a:t>
+              <a:t>Voter-roll revisions under SIR were not captured in our population data.</a:t>
             </a:r>
             <a:endParaRPr lang="en-US" sz="1800" dirty="0"/>
           </a:p>
@@ -4815,7 +4815,7 @@
                 <a:ea typeface="Calibri" pitchFamily="34" charset="-122"/>
                 <a:cs typeface="Calibri" pitchFamily="34" charset="-120"/>
               </a:rPr>
-              <a:t>Systematic deletion of names in Muslim-majority blocks in North Bengal and Murshidabad. Not visible from published rolls at modelling time; no signal in our population layer.</a:t>
+              <a:t>Name deletions across multiple blocks in North Bengal and Murshidabad created a turnout asymmetry our population layer did not account for. No per-block attrition signal was available at modelling time.</a:t>
             </a:r>
             <a:endParaRPr lang="en-US" sz="1200" dirty="0"/>
           </a:p>
@@ -5010,7 +5010,7 @@
                 <a:ea typeface="Arial Narrow" pitchFamily="34" charset="-122"/>
                 <a:cs typeface="Arial Narrow" pitchFamily="34" charset="-120"/>
               </a:rPr>
-              <a:t>2026 became a Hindu identity election, not a welfare election.</a:t>
+              <a:t>The mobilisation frame shifted from welfare delivery to political consolidation.</a:t>
             </a:r>
             <a:endParaRPr lang="en-US" sz="1800" dirty="0"/>
           </a:p>
@@ -5049,7 +5049,7 @@
                 <a:ea typeface="Calibri" pitchFamily="34" charset="-122"/>
                 <a:cs typeface="Calibri" pitchFamily="34" charset="-120"/>
               </a:rPr>
-              <a:t>The simulation ran on welfare delivery signals (beneficiary schemes, Duare Sarkar reach). The operative frame on election day was religio-cultural consolidation — orthogonal to our model.</a:t>
+              <a:t>The simulation's signal layer was built on scheme reach and beneficiary satisfaction. The dominant operative dynamic on election day was cross-community political consolidation — a frame welfare metrics cannot proxy.</a:t>
             </a:r>
             <a:endParaRPr lang="en-US" sz="1200" dirty="0"/>
           </a:p>

</xml_diff>